<commit_message>
feat(minha-equipe): equipe BB Cadastro no Contencioso Passivo - slug bb-cadastro no registro canonico (gate/endpoints), item no menu e arvore de permissoes, aba BB CADASTRO da planilha de squads mapeada no seed (entra no roster no proximo ingest)
</commit_message>
<xml_diff>
--- a/docs/DunaFlow_Apresentacao.pptx
+++ b/docs/DunaFlow_Apresentacao.pptx
@@ -2621,7 +2621,7 @@
                 <a:ea typeface="Calibri" pitchFamily="34" charset="-122"/>
                 <a:cs typeface="Calibri" pitchFamily="34" charset="-120"/>
               </a:rPr>
-              <a:t>Abril · 2026   ·   v1.5</a:t>
+              <a:t>Abril · 2026   ·   v1.6</a:t>
             </a:r>
             <a:endParaRPr lang="en-US" sz="1100" dirty="0"/>
           </a:p>
@@ -8994,7 +8994,7 @@
                 <a:ea typeface="Calibri" pitchFamily="34" charset="-122"/>
                 <a:cs typeface="Calibri" pitchFamily="34" charset="-120"/>
               </a:rPr>
-              <a:t>MDR Advocacia  ·  DunaFlow v1.5 · by DUNATECH  ·  Abril · 2026</a:t>
+              <a:t>MDR Advocacia  ·  DunaFlow v1.6 · by DUNATECH  ·  Abril · 2026</a:t>
             </a:r>
             <a:endParaRPr lang="en-US" sz="1000" dirty="0"/>
           </a:p>
@@ -10791,7 +10791,7 @@
                 <a:ea typeface="Georgia" pitchFamily="34" charset="-122"/>
                 <a:cs typeface="Georgia" pitchFamily="34" charset="-120"/>
               </a:rPr>
-              <a:t>Oito módulos, uma única base operacional</a:t>
+              <a:t>Doze módulos organizados em quatro famílias</a:t>
             </a:r>
             <a:endParaRPr lang="en-US" sz="3000" dirty="0"/>
           </a:p>
@@ -10830,8 +10830,8 @@
         </p:nvSpPr>
         <p:spPr>
           <a:xfrm>
-            <a:off x="402336" y="1737360"/>
-            <a:ext cx="2743200" cy="2194560"/>
+            <a:off x="457200" y="1691640"/>
+            <a:ext cx="2743200" cy="4709160"/>
           </a:xfrm>
           <a:prstGeom prst="rect">
             <a:avLst/>
@@ -10862,56 +10862,32 @@
         </p:nvSpPr>
         <p:spPr>
           <a:xfrm>
-            <a:off x="402336" y="1737360"/>
-            <a:ext cx="2743200" cy="73152"/>
+            <a:off x="457200" y="1691640"/>
+            <a:ext cx="2743200" cy="777240"/>
           </a:xfrm>
           <a:prstGeom prst="rect">
             <a:avLst/>
           </a:prstGeom>
           <a:solidFill>
-            <a:srgbClr val="0A1940"/>
+            <a:srgbClr val="1E7BFF"/>
           </a:solidFill>
           <a:ln w="12700">
             <a:solidFill>
-              <a:srgbClr val="0A1940"/>
+              <a:srgbClr val="1E7BFF"/>
             </a:solidFill>
             <a:prstDash val="solid"/>
           </a:ln>
         </p:spPr>
       </p:sp>
-      <p:pic>
-        <p:nvPicPr>
-          <p:cNvPr id="7" name="Image 0" descr="preencoded.png">    </p:cNvPr>
-          <p:cNvPicPr>
-            <a:picLocks noChangeAspect="1"/>
-          </p:cNvPicPr>
-          <p:nvPr/>
-        </p:nvPicPr>
-        <p:blipFill>
-          <a:blip r:embed="rId1"/>
-          <a:stretch>
-            <a:fillRect/>
-          </a:stretch>
-        </p:blipFill>
-        <p:spPr>
-          <a:xfrm>
-            <a:off x="676656" y="2103120"/>
-            <a:ext cx="548640" cy="548640"/>
-          </a:xfrm>
-          <a:prstGeom prst="rect">
-            <a:avLst/>
-          </a:prstGeom>
-        </p:spPr>
-      </p:pic>
-      <p:sp>
-        <p:nvSpPr>
-          <p:cNvPr id="8" name="Text 5"/>
-          <p:cNvSpPr/>
-          <p:nvPr/>
-        </p:nvSpPr>
-        <p:spPr>
-          <a:xfrm>
-            <a:off x="630936" y="2788920"/>
+      <p:sp>
+        <p:nvSpPr>
+          <p:cNvPr id="7" name="Text 5"/>
+          <p:cNvSpPr/>
+          <p:nvPr/>
+        </p:nvSpPr>
+        <p:spPr>
+          <a:xfrm>
+            <a:off x="685800" y="1801368"/>
             <a:ext cx="2286000" cy="365760"/>
           </a:xfrm>
           <a:prstGeom prst="rect">
@@ -10928,15 +10904,15 @@
               <a:buNone/>
             </a:pPr>
             <a:r>
-              <a:rPr lang="en-US" sz="1500" b="1" dirty="0">
-                <a:solidFill>
-                  <a:srgbClr val="0A1940"/>
+              <a:rPr lang="en-US" sz="1500" b="1" spc="400" kern="0" dirty="0">
+                <a:solidFill>
+                  <a:srgbClr val="FFFFFF"/>
                 </a:solidFill>
                 <a:latin typeface="Georgia" pitchFamily="34" charset="0"/>
                 <a:ea typeface="Georgia" pitchFamily="34" charset="-122"/>
                 <a:cs typeface="Georgia" pitchFamily="34" charset="-120"/>
               </a:rPr>
-              <a:t>Criação em lote</a:t>
+              <a:t>INGESTÃO</a:t>
             </a:r>
             <a:endParaRPr lang="en-US" sz="1500" dirty="0"/>
           </a:p>
@@ -10944,30 +10920,158 @@
       </p:sp>
       <p:sp>
         <p:nvSpPr>
-          <p:cNvPr id="9" name="Text 6"/>
-          <p:cNvSpPr/>
-          <p:nvPr/>
-        </p:nvSpPr>
-        <p:spPr>
-          <a:xfrm>
-            <a:off x="630936" y="3108960"/>
-            <a:ext cx="2286000" cy="777240"/>
-          </a:xfrm>
-          <a:prstGeom prst="rect">
-            <a:avLst/>
-          </a:prstGeom>
-          <a:noFill/>
-          <a:ln/>
-        </p:spPr>
-        <p:txBody>
-          <a:bodyPr wrap="square" lIns="0" tIns="0" rIns="0" bIns="0" rtlCol="0" anchor="ctr"/>
-          <a:lstStyle/>
-          <a:p>
-            <a:pPr indent="0" marL="0">
-              <a:buNone/>
-            </a:pPr>
-            <a:r>
-              <a:rPr lang="en-US" sz="1100" dirty="0">
+          <p:cNvPr id="8" name="Text 6"/>
+          <p:cNvSpPr/>
+          <p:nvPr/>
+        </p:nvSpPr>
+        <p:spPr>
+          <a:xfrm>
+            <a:off x="685800" y="2148840"/>
+            <a:ext cx="2286000" cy="274320"/>
+          </a:xfrm>
+          <a:prstGeom prst="rect">
+            <a:avLst/>
+          </a:prstGeom>
+          <a:noFill/>
+          <a:ln/>
+        </p:spPr>
+        <p:txBody>
+          <a:bodyPr wrap="square" lIns="0" tIns="0" rIns="0" bIns="0" rtlCol="0" anchor="ctr"/>
+          <a:lstStyle/>
+          <a:p>
+            <a:pPr indent="0" marL="0">
+              <a:buNone/>
+            </a:pPr>
+            <a:r>
+              <a:rPr lang="en-US" sz="1000" i="1" dirty="0">
+                <a:solidFill>
+                  <a:srgbClr val="DCE6F7"/>
+                </a:solidFill>
+                <a:latin typeface="Calibri" pitchFamily="34" charset="0"/>
+                <a:ea typeface="Calibri" pitchFamily="34" charset="-122"/>
+                <a:cs typeface="Calibri" pitchFamily="34" charset="-120"/>
+              </a:rPr>
+              <a:t>O que entra</a:t>
+            </a:r>
+            <a:endParaRPr lang="en-US" sz="1000" dirty="0"/>
+          </a:p>
+        </p:txBody>
+      </p:sp>
+      <p:sp>
+        <p:nvSpPr>
+          <p:cNvPr id="9" name="Shape 7"/>
+          <p:cNvSpPr/>
+          <p:nvPr/>
+        </p:nvSpPr>
+        <p:spPr>
+          <a:xfrm>
+            <a:off x="594360" y="2578608"/>
+            <a:ext cx="2468880" cy="1234440"/>
+          </a:xfrm>
+          <a:prstGeom prst="rect">
+            <a:avLst/>
+          </a:prstGeom>
+          <a:solidFill>
+            <a:srgbClr val="F4F6FB"/>
+          </a:solidFill>
+          <a:ln w="5080">
+            <a:solidFill>
+              <a:srgbClr val="E2E8F0"/>
+            </a:solidFill>
+            <a:prstDash val="solid"/>
+          </a:ln>
+        </p:spPr>
+      </p:sp>
+      <p:sp>
+        <p:nvSpPr>
+          <p:cNvPr id="10" name="Shape 8"/>
+          <p:cNvSpPr/>
+          <p:nvPr/>
+        </p:nvSpPr>
+        <p:spPr>
+          <a:xfrm>
+            <a:off x="594360" y="2578608"/>
+            <a:ext cx="73152" cy="1234440"/>
+          </a:xfrm>
+          <a:prstGeom prst="rect">
+            <a:avLst/>
+          </a:prstGeom>
+          <a:solidFill>
+            <a:srgbClr val="1E7BFF"/>
+          </a:solidFill>
+          <a:ln w="12700">
+            <a:solidFill>
+              <a:srgbClr val="1E7BFF"/>
+            </a:solidFill>
+            <a:prstDash val="solid"/>
+          </a:ln>
+        </p:spPr>
+      </p:sp>
+      <p:sp>
+        <p:nvSpPr>
+          <p:cNvPr id="11" name="Text 9"/>
+          <p:cNvSpPr/>
+          <p:nvPr/>
+        </p:nvSpPr>
+        <p:spPr>
+          <a:xfrm>
+            <a:off x="749808" y="2743200"/>
+            <a:ext cx="2313432" cy="457200"/>
+          </a:xfrm>
+          <a:prstGeom prst="rect">
+            <a:avLst/>
+          </a:prstGeom>
+          <a:noFill/>
+          <a:ln/>
+        </p:spPr>
+        <p:txBody>
+          <a:bodyPr wrap="square" lIns="0" tIns="0" rIns="0" bIns="0" rtlCol="0" anchor="ctr"/>
+          <a:lstStyle/>
+          <a:p>
+            <a:pPr indent="0" marL="0">
+              <a:buNone/>
+            </a:pPr>
+            <a:r>
+              <a:rPr lang="en-US" sz="1300" b="1" dirty="0">
+                <a:solidFill>
+                  <a:srgbClr val="0A1940"/>
+                </a:solidFill>
+                <a:latin typeface="Georgia" pitchFamily="34" charset="0"/>
+                <a:ea typeface="Georgia" pitchFamily="34" charset="-122"/>
+                <a:cs typeface="Georgia" pitchFamily="34" charset="-120"/>
+              </a:rPr>
+              <a:t>Publicações</a:t>
+            </a:r>
+            <a:endParaRPr lang="en-US" sz="1300" dirty="0"/>
+          </a:p>
+        </p:txBody>
+      </p:sp>
+      <p:sp>
+        <p:nvSpPr>
+          <p:cNvPr id="12" name="Text 10"/>
+          <p:cNvSpPr/>
+          <p:nvPr/>
+        </p:nvSpPr>
+        <p:spPr>
+          <a:xfrm>
+            <a:off x="749808" y="3218688"/>
+            <a:ext cx="2313432" cy="502920"/>
+          </a:xfrm>
+          <a:prstGeom prst="rect">
+            <a:avLst/>
+          </a:prstGeom>
+          <a:noFill/>
+          <a:ln/>
+        </p:spPr>
+        <p:txBody>
+          <a:bodyPr wrap="square" lIns="0" tIns="0" rIns="0" bIns="0" rtlCol="0" anchor="ctr"/>
+          <a:lstStyle/>
+          <a:p>
+            <a:pPr indent="0" marL="0">
+              <a:buNone/>
+            </a:pPr>
+            <a:r>
+              <a:rPr lang="en-US" sz="1000" dirty="0">
                 <a:solidFill>
                   <a:srgbClr val="1E293B"/>
                 </a:solidFill>
@@ -10975,22 +11079,278 @@
                 <a:ea typeface="Calibri" pitchFamily="34" charset="-122"/>
                 <a:cs typeface="Calibri" pitchFamily="34" charset="-120"/>
               </a:rPr>
-              <a:t>Milhares de tarefas por execução, com histórico auditável.</a:t>
-            </a:r>
-            <a:endParaRPr lang="en-US" sz="1100" dirty="0"/>
-          </a:p>
-        </p:txBody>
-      </p:sp>
-      <p:sp>
-        <p:nvSpPr>
-          <p:cNvPr id="10" name="Shape 7"/>
-          <p:cNvSpPr/>
-          <p:nvPr/>
-        </p:nvSpPr>
-        <p:spPr>
-          <a:xfrm>
-            <a:off x="3282696" y="1737360"/>
-            <a:ext cx="2743200" cy="2194560"/>
+              <a:t>Diário oficial (DJEN)</a:t>
+            </a:r>
+            <a:endParaRPr lang="en-US" sz="1000" dirty="0"/>
+          </a:p>
+        </p:txBody>
+      </p:sp>
+      <p:sp>
+        <p:nvSpPr>
+          <p:cNvPr id="13" name="Shape 11"/>
+          <p:cNvSpPr/>
+          <p:nvPr/>
+        </p:nvSpPr>
+        <p:spPr>
+          <a:xfrm>
+            <a:off x="594360" y="3858768"/>
+            <a:ext cx="2468880" cy="1234440"/>
+          </a:xfrm>
+          <a:prstGeom prst="rect">
+            <a:avLst/>
+          </a:prstGeom>
+          <a:solidFill>
+            <a:srgbClr val="F4F6FB"/>
+          </a:solidFill>
+          <a:ln w="5080">
+            <a:solidFill>
+              <a:srgbClr val="E2E8F0"/>
+            </a:solidFill>
+            <a:prstDash val="solid"/>
+          </a:ln>
+        </p:spPr>
+      </p:sp>
+      <p:sp>
+        <p:nvSpPr>
+          <p:cNvPr id="14" name="Shape 12"/>
+          <p:cNvSpPr/>
+          <p:nvPr/>
+        </p:nvSpPr>
+        <p:spPr>
+          <a:xfrm>
+            <a:off x="594360" y="3858768"/>
+            <a:ext cx="73152" cy="1234440"/>
+          </a:xfrm>
+          <a:prstGeom prst="rect">
+            <a:avLst/>
+          </a:prstGeom>
+          <a:solidFill>
+            <a:srgbClr val="1E7BFF"/>
+          </a:solidFill>
+          <a:ln w="12700">
+            <a:solidFill>
+              <a:srgbClr val="1E7BFF"/>
+            </a:solidFill>
+            <a:prstDash val="solid"/>
+          </a:ln>
+        </p:spPr>
+      </p:sp>
+      <p:sp>
+        <p:nvSpPr>
+          <p:cNvPr id="15" name="Text 13"/>
+          <p:cNvSpPr/>
+          <p:nvPr/>
+        </p:nvSpPr>
+        <p:spPr>
+          <a:xfrm>
+            <a:off x="749808" y="4023360"/>
+            <a:ext cx="2313432" cy="457200"/>
+          </a:xfrm>
+          <a:prstGeom prst="rect">
+            <a:avLst/>
+          </a:prstGeom>
+          <a:noFill/>
+          <a:ln/>
+        </p:spPr>
+        <p:txBody>
+          <a:bodyPr wrap="square" lIns="0" tIns="0" rIns="0" bIns="0" rtlCol="0" anchor="ctr"/>
+          <a:lstStyle/>
+          <a:p>
+            <a:pPr indent="0" marL="0">
+              <a:buNone/>
+            </a:pPr>
+            <a:r>
+              <a:rPr lang="en-US" sz="1300" b="1" dirty="0">
+                <a:solidFill>
+                  <a:srgbClr val="0A1940"/>
+                </a:solidFill>
+                <a:latin typeface="Georgia" pitchFamily="34" charset="0"/>
+                <a:ea typeface="Georgia" pitchFamily="34" charset="-122"/>
+                <a:cs typeface="Georgia" pitchFamily="34" charset="-120"/>
+              </a:rPr>
+              <a:t>OneRequest</a:t>
+            </a:r>
+            <a:endParaRPr lang="en-US" sz="1300" dirty="0"/>
+          </a:p>
+        </p:txBody>
+      </p:sp>
+      <p:sp>
+        <p:nvSpPr>
+          <p:cNvPr id="16" name="Text 14"/>
+          <p:cNvSpPr/>
+          <p:nvPr/>
+        </p:nvSpPr>
+        <p:spPr>
+          <a:xfrm>
+            <a:off x="749808" y="4498848"/>
+            <a:ext cx="2313432" cy="502920"/>
+          </a:xfrm>
+          <a:prstGeom prst="rect">
+            <a:avLst/>
+          </a:prstGeom>
+          <a:noFill/>
+          <a:ln/>
+        </p:spPr>
+        <p:txBody>
+          <a:bodyPr wrap="square" lIns="0" tIns="0" rIns="0" bIns="0" rtlCol="0" anchor="ctr"/>
+          <a:lstStyle/>
+          <a:p>
+            <a:pPr indent="0" marL="0">
+              <a:buNone/>
+            </a:pPr>
+            <a:r>
+              <a:rPr lang="en-US" sz="1000" dirty="0">
+                <a:solidFill>
+                  <a:srgbClr val="1E293B"/>
+                </a:solidFill>
+                <a:latin typeface="Calibri" pitchFamily="34" charset="0"/>
+                <a:ea typeface="Calibri" pitchFamily="34" charset="-122"/>
+                <a:cs typeface="Calibri" pitchFamily="34" charset="-120"/>
+              </a:rPr>
+              <a:t>DMIs do Banco do Brasil</a:t>
+            </a:r>
+            <a:endParaRPr lang="en-US" sz="1000" dirty="0"/>
+          </a:p>
+        </p:txBody>
+      </p:sp>
+      <p:sp>
+        <p:nvSpPr>
+          <p:cNvPr id="17" name="Shape 15"/>
+          <p:cNvSpPr/>
+          <p:nvPr/>
+        </p:nvSpPr>
+        <p:spPr>
+          <a:xfrm>
+            <a:off x="594360" y="5138928"/>
+            <a:ext cx="2468880" cy="1234440"/>
+          </a:xfrm>
+          <a:prstGeom prst="rect">
+            <a:avLst/>
+          </a:prstGeom>
+          <a:solidFill>
+            <a:srgbClr val="F4F6FB"/>
+          </a:solidFill>
+          <a:ln w="5080">
+            <a:solidFill>
+              <a:srgbClr val="E2E8F0"/>
+            </a:solidFill>
+            <a:prstDash val="solid"/>
+          </a:ln>
+        </p:spPr>
+      </p:sp>
+      <p:sp>
+        <p:nvSpPr>
+          <p:cNvPr id="18" name="Shape 16"/>
+          <p:cNvSpPr/>
+          <p:nvPr/>
+        </p:nvSpPr>
+        <p:spPr>
+          <a:xfrm>
+            <a:off x="594360" y="5138928"/>
+            <a:ext cx="73152" cy="1234440"/>
+          </a:xfrm>
+          <a:prstGeom prst="rect">
+            <a:avLst/>
+          </a:prstGeom>
+          <a:solidFill>
+            <a:srgbClr val="1E7BFF"/>
+          </a:solidFill>
+          <a:ln w="12700">
+            <a:solidFill>
+              <a:srgbClr val="1E7BFF"/>
+            </a:solidFill>
+            <a:prstDash val="solid"/>
+          </a:ln>
+        </p:spPr>
+      </p:sp>
+      <p:sp>
+        <p:nvSpPr>
+          <p:cNvPr id="19" name="Text 17"/>
+          <p:cNvSpPr/>
+          <p:nvPr/>
+        </p:nvSpPr>
+        <p:spPr>
+          <a:xfrm>
+            <a:off x="749808" y="5303520"/>
+            <a:ext cx="2313432" cy="457200"/>
+          </a:xfrm>
+          <a:prstGeom prst="rect">
+            <a:avLst/>
+          </a:prstGeom>
+          <a:noFill/>
+          <a:ln/>
+        </p:spPr>
+        <p:txBody>
+          <a:bodyPr wrap="square" lIns="0" tIns="0" rIns="0" bIns="0" rtlCol="0" anchor="ctr"/>
+          <a:lstStyle/>
+          <a:p>
+            <a:pPr indent="0" marL="0">
+              <a:buNone/>
+            </a:pPr>
+            <a:r>
+              <a:rPr lang="en-US" sz="1300" b="1" dirty="0">
+                <a:solidFill>
+                  <a:srgbClr val="0A1940"/>
+                </a:solidFill>
+                <a:latin typeface="Georgia" pitchFamily="34" charset="0"/>
+                <a:ea typeface="Georgia" pitchFamily="34" charset="-122"/>
+                <a:cs typeface="Georgia" pitchFamily="34" charset="-120"/>
+              </a:rPr>
+              <a:t>Prazos Processuais</a:t>
+            </a:r>
+            <a:endParaRPr lang="en-US" sz="1300" dirty="0"/>
+          </a:p>
+        </p:txBody>
+      </p:sp>
+      <p:sp>
+        <p:nvSpPr>
+          <p:cNvPr id="20" name="Text 18"/>
+          <p:cNvSpPr/>
+          <p:nvPr/>
+        </p:nvSpPr>
+        <p:spPr>
+          <a:xfrm>
+            <a:off x="749808" y="5779008"/>
+            <a:ext cx="2313432" cy="502920"/>
+          </a:xfrm>
+          <a:prstGeom prst="rect">
+            <a:avLst/>
+          </a:prstGeom>
+          <a:noFill/>
+          <a:ln/>
+        </p:spPr>
+        <p:txBody>
+          <a:bodyPr wrap="square" lIns="0" tIns="0" rIns="0" bIns="0" rtlCol="0" anchor="ctr"/>
+          <a:lstStyle/>
+          <a:p>
+            <a:pPr indent="0" marL="0">
+              <a:buNone/>
+            </a:pPr>
+            <a:r>
+              <a:rPr lang="en-US" sz="1000" dirty="0">
+                <a:solidFill>
+                  <a:srgbClr val="1E293B"/>
+                </a:solidFill>
+                <a:latin typeface="Calibri" pitchFamily="34" charset="0"/>
+                <a:ea typeface="Calibri" pitchFamily="34" charset="-122"/>
+                <a:cs typeface="Calibri" pitchFamily="34" charset="-120"/>
+              </a:rPr>
+              <a:t>Intake da petição inicial</a:t>
+            </a:r>
+            <a:endParaRPr lang="en-US" sz="1000" dirty="0"/>
+          </a:p>
+        </p:txBody>
+      </p:sp>
+      <p:sp>
+        <p:nvSpPr>
+          <p:cNvPr id="21" name="Shape 19"/>
+          <p:cNvSpPr/>
+          <p:nvPr/>
+        </p:nvSpPr>
+        <p:spPr>
+          <a:xfrm>
+            <a:off x="3300984" y="1691640"/>
+            <a:ext cx="2743200" cy="4709160"/>
           </a:xfrm>
           <a:prstGeom prst="rect">
             <a:avLst/>
@@ -11015,14 +11375,14 @@
       </p:sp>
       <p:sp>
         <p:nvSpPr>
-          <p:cNvPr id="11" name="Shape 8"/>
-          <p:cNvSpPr/>
-          <p:nvPr/>
-        </p:nvSpPr>
-        <p:spPr>
-          <a:xfrm>
-            <a:off x="3282696" y="1737360"/>
-            <a:ext cx="2743200" cy="73152"/>
+          <p:cNvPr id="22" name="Shape 20"/>
+          <p:cNvSpPr/>
+          <p:nvPr/>
+        </p:nvSpPr>
+        <p:spPr>
+          <a:xfrm>
+            <a:off x="3300984" y="1691640"/>
+            <a:ext cx="2743200" cy="777240"/>
           </a:xfrm>
           <a:prstGeom prst="rect">
             <a:avLst/>
@@ -11038,39 +11398,15 @@
           </a:ln>
         </p:spPr>
       </p:sp>
-      <p:pic>
-        <p:nvPicPr>
-          <p:cNvPr id="12" name="Image 1" descr="preencoded.png">    </p:cNvPr>
-          <p:cNvPicPr>
-            <a:picLocks noChangeAspect="1"/>
-          </p:cNvPicPr>
-          <p:nvPr/>
-        </p:nvPicPr>
-        <p:blipFill>
-          <a:blip r:embed="rId2"/>
-          <a:stretch>
-            <a:fillRect/>
-          </a:stretch>
-        </p:blipFill>
-        <p:spPr>
-          <a:xfrm>
-            <a:off x="3557016" y="2103120"/>
-            <a:ext cx="548640" cy="548640"/>
-          </a:xfrm>
-          <a:prstGeom prst="rect">
-            <a:avLst/>
-          </a:prstGeom>
-        </p:spPr>
-      </p:pic>
-      <p:sp>
-        <p:nvSpPr>
-          <p:cNvPr id="13" name="Text 9"/>
-          <p:cNvSpPr/>
-          <p:nvPr/>
-        </p:nvSpPr>
-        <p:spPr>
-          <a:xfrm>
-            <a:off x="3511296" y="2788920"/>
+      <p:sp>
+        <p:nvSpPr>
+          <p:cNvPr id="23" name="Text 21"/>
+          <p:cNvSpPr/>
+          <p:nvPr/>
+        </p:nvSpPr>
+        <p:spPr>
+          <a:xfrm>
+            <a:off x="3529584" y="1801368"/>
             <a:ext cx="2286000" cy="365760"/>
           </a:xfrm>
           <a:prstGeom prst="rect">
@@ -11087,15 +11423,15 @@
               <a:buNone/>
             </a:pPr>
             <a:r>
-              <a:rPr lang="en-US" sz="1500" b="1" dirty="0">
-                <a:solidFill>
-                  <a:srgbClr val="0A1940"/>
+              <a:rPr lang="en-US" sz="1500" b="1" spc="400" kern="0" dirty="0">
+                <a:solidFill>
+                  <a:srgbClr val="FFFFFF"/>
                 </a:solidFill>
                 <a:latin typeface="Georgia" pitchFamily="34" charset="0"/>
                 <a:ea typeface="Georgia" pitchFamily="34" charset="-122"/>
                 <a:cs typeface="Georgia" pitchFamily="34" charset="-120"/>
               </a:rPr>
-              <a:t>Classificação com IA</a:t>
+              <a:t>OPERAÇÃO</a:t>
             </a:r>
             <a:endParaRPr lang="en-US" sz="1500" dirty="0"/>
           </a:p>
@@ -11103,30 +11439,158 @@
       </p:sp>
       <p:sp>
         <p:nvSpPr>
-          <p:cNvPr id="14" name="Text 10"/>
-          <p:cNvSpPr/>
-          <p:nvPr/>
-        </p:nvSpPr>
-        <p:spPr>
-          <a:xfrm>
-            <a:off x="3511296" y="3108960"/>
-            <a:ext cx="2286000" cy="777240"/>
-          </a:xfrm>
-          <a:prstGeom prst="rect">
-            <a:avLst/>
-          </a:prstGeom>
-          <a:noFill/>
-          <a:ln/>
-        </p:spPr>
-        <p:txBody>
-          <a:bodyPr wrap="square" lIns="0" tIns="0" rIns="0" bIns="0" rtlCol="0" anchor="ctr"/>
-          <a:lstStyle/>
-          <a:p>
-            <a:pPr indent="0" marL="0">
-              <a:buNone/>
-            </a:pPr>
-            <a:r>
-              <a:rPr lang="en-US" sz="1100" dirty="0">
+          <p:cNvPr id="24" name="Text 22"/>
+          <p:cNvSpPr/>
+          <p:nvPr/>
+        </p:nvSpPr>
+        <p:spPr>
+          <a:xfrm>
+            <a:off x="3529584" y="2148840"/>
+            <a:ext cx="2286000" cy="274320"/>
+          </a:xfrm>
+          <a:prstGeom prst="rect">
+            <a:avLst/>
+          </a:prstGeom>
+          <a:noFill/>
+          <a:ln/>
+        </p:spPr>
+        <p:txBody>
+          <a:bodyPr wrap="square" lIns="0" tIns="0" rIns="0" bIns="0" rtlCol="0" anchor="ctr"/>
+          <a:lstStyle/>
+          <a:p>
+            <a:pPr indent="0" marL="0">
+              <a:buNone/>
+            </a:pPr>
+            <a:r>
+              <a:rPr lang="en-US" sz="1000" i="1" dirty="0">
+                <a:solidFill>
+                  <a:srgbClr val="DCE6F7"/>
+                </a:solidFill>
+                <a:latin typeface="Calibri" pitchFamily="34" charset="0"/>
+                <a:ea typeface="Calibri" pitchFamily="34" charset="-122"/>
+                <a:cs typeface="Calibri" pitchFamily="34" charset="-120"/>
+              </a:rPr>
+              <a:t>Como a plataforma age</a:t>
+            </a:r>
+            <a:endParaRPr lang="en-US" sz="1000" dirty="0"/>
+          </a:p>
+        </p:txBody>
+      </p:sp>
+      <p:sp>
+        <p:nvSpPr>
+          <p:cNvPr id="25" name="Shape 23"/>
+          <p:cNvSpPr/>
+          <p:nvPr/>
+        </p:nvSpPr>
+        <p:spPr>
+          <a:xfrm>
+            <a:off x="3438144" y="2578608"/>
+            <a:ext cx="2468880" cy="1234440"/>
+          </a:xfrm>
+          <a:prstGeom prst="rect">
+            <a:avLst/>
+          </a:prstGeom>
+          <a:solidFill>
+            <a:srgbClr val="F4F6FB"/>
+          </a:solidFill>
+          <a:ln w="5080">
+            <a:solidFill>
+              <a:srgbClr val="E2E8F0"/>
+            </a:solidFill>
+            <a:prstDash val="solid"/>
+          </a:ln>
+        </p:spPr>
+      </p:sp>
+      <p:sp>
+        <p:nvSpPr>
+          <p:cNvPr id="26" name="Shape 24"/>
+          <p:cNvSpPr/>
+          <p:nvPr/>
+        </p:nvSpPr>
+        <p:spPr>
+          <a:xfrm>
+            <a:off x="3438144" y="2578608"/>
+            <a:ext cx="73152" cy="1234440"/>
+          </a:xfrm>
+          <a:prstGeom prst="rect">
+            <a:avLst/>
+          </a:prstGeom>
+          <a:solidFill>
+            <a:srgbClr val="0A1940"/>
+          </a:solidFill>
+          <a:ln w="12700">
+            <a:solidFill>
+              <a:srgbClr val="0A1940"/>
+            </a:solidFill>
+            <a:prstDash val="solid"/>
+          </a:ln>
+        </p:spPr>
+      </p:sp>
+      <p:sp>
+        <p:nvSpPr>
+          <p:cNvPr id="27" name="Text 25"/>
+          <p:cNvSpPr/>
+          <p:nvPr/>
+        </p:nvSpPr>
+        <p:spPr>
+          <a:xfrm>
+            <a:off x="3593592" y="2743200"/>
+            <a:ext cx="2313432" cy="457200"/>
+          </a:xfrm>
+          <a:prstGeom prst="rect">
+            <a:avLst/>
+          </a:prstGeom>
+          <a:noFill/>
+          <a:ln/>
+        </p:spPr>
+        <p:txBody>
+          <a:bodyPr wrap="square" lIns="0" tIns="0" rIns="0" bIns="0" rtlCol="0" anchor="ctr"/>
+          <a:lstStyle/>
+          <a:p>
+            <a:pPr indent="0" marL="0">
+              <a:buNone/>
+            </a:pPr>
+            <a:r>
+              <a:rPr lang="en-US" sz="1300" b="1" dirty="0">
+                <a:solidFill>
+                  <a:srgbClr val="0A1940"/>
+                </a:solidFill>
+                <a:latin typeface="Georgia" pitchFamily="34" charset="0"/>
+                <a:ea typeface="Georgia" pitchFamily="34" charset="-122"/>
+                <a:cs typeface="Georgia" pitchFamily="34" charset="-120"/>
+              </a:rPr>
+              <a:t>Classificação IA</a:t>
+            </a:r>
+            <a:endParaRPr lang="en-US" sz="1300" dirty="0"/>
+          </a:p>
+        </p:txBody>
+      </p:sp>
+      <p:sp>
+        <p:nvSpPr>
+          <p:cNvPr id="28" name="Text 26"/>
+          <p:cNvSpPr/>
+          <p:nvPr/>
+        </p:nvSpPr>
+        <p:spPr>
+          <a:xfrm>
+            <a:off x="3593592" y="3218688"/>
+            <a:ext cx="2313432" cy="502920"/>
+          </a:xfrm>
+          <a:prstGeom prst="rect">
+            <a:avLst/>
+          </a:prstGeom>
+          <a:noFill/>
+          <a:ln/>
+        </p:spPr>
+        <p:txBody>
+          <a:bodyPr wrap="square" lIns="0" tIns="0" rIns="0" bIns="0" rtlCol="0" anchor="ctr"/>
+          <a:lstStyle/>
+          <a:p>
+            <a:pPr indent="0" marL="0">
+              <a:buNone/>
+            </a:pPr>
+            <a:r>
+              <a:rPr lang="en-US" sz="1000" dirty="0">
                 <a:solidFill>
                   <a:srgbClr val="1E293B"/>
                 </a:solidFill>
@@ -11134,22 +11598,278 @@
                 <a:ea typeface="Calibri" pitchFamily="34" charset="-122"/>
                 <a:cs typeface="Calibri" pitchFamily="34" charset="-120"/>
               </a:rPr>
-              <a:t>Haiku 4.5 + Batch API a custo marginal.</a:t>
-            </a:r>
-            <a:endParaRPr lang="en-US" sz="1100" dirty="0"/>
-          </a:p>
-        </p:txBody>
-      </p:sp>
-      <p:sp>
-        <p:nvSpPr>
-          <p:cNvPr id="15" name="Shape 11"/>
-          <p:cNvSpPr/>
-          <p:nvPr/>
-        </p:nvSpPr>
-        <p:spPr>
-          <a:xfrm>
-            <a:off x="6163056" y="1737360"/>
-            <a:ext cx="2743200" cy="2194560"/>
+              <a:t>Haiku 4.5 + Batch API</a:t>
+            </a:r>
+            <a:endParaRPr lang="en-US" sz="1000" dirty="0"/>
+          </a:p>
+        </p:txBody>
+      </p:sp>
+      <p:sp>
+        <p:nvSpPr>
+          <p:cNvPr id="29" name="Shape 27"/>
+          <p:cNvSpPr/>
+          <p:nvPr/>
+        </p:nvSpPr>
+        <p:spPr>
+          <a:xfrm>
+            <a:off x="3438144" y="3858768"/>
+            <a:ext cx="2468880" cy="1234440"/>
+          </a:xfrm>
+          <a:prstGeom prst="rect">
+            <a:avLst/>
+          </a:prstGeom>
+          <a:solidFill>
+            <a:srgbClr val="F4F6FB"/>
+          </a:solidFill>
+          <a:ln w="5080">
+            <a:solidFill>
+              <a:srgbClr val="E2E8F0"/>
+            </a:solidFill>
+            <a:prstDash val="solid"/>
+          </a:ln>
+        </p:spPr>
+      </p:sp>
+      <p:sp>
+        <p:nvSpPr>
+          <p:cNvPr id="30" name="Shape 28"/>
+          <p:cNvSpPr/>
+          <p:nvPr/>
+        </p:nvSpPr>
+        <p:spPr>
+          <a:xfrm>
+            <a:off x="3438144" y="3858768"/>
+            <a:ext cx="73152" cy="1234440"/>
+          </a:xfrm>
+          <a:prstGeom prst="rect">
+            <a:avLst/>
+          </a:prstGeom>
+          <a:solidFill>
+            <a:srgbClr val="0A1940"/>
+          </a:solidFill>
+          <a:ln w="12700">
+            <a:solidFill>
+              <a:srgbClr val="0A1940"/>
+            </a:solidFill>
+            <a:prstDash val="solid"/>
+          </a:ln>
+        </p:spPr>
+      </p:sp>
+      <p:sp>
+        <p:nvSpPr>
+          <p:cNvPr id="31" name="Text 29"/>
+          <p:cNvSpPr/>
+          <p:nvPr/>
+        </p:nvSpPr>
+        <p:spPr>
+          <a:xfrm>
+            <a:off x="3593592" y="4023360"/>
+            <a:ext cx="2313432" cy="457200"/>
+          </a:xfrm>
+          <a:prstGeom prst="rect">
+            <a:avLst/>
+          </a:prstGeom>
+          <a:noFill/>
+          <a:ln/>
+        </p:spPr>
+        <p:txBody>
+          <a:bodyPr wrap="square" lIns="0" tIns="0" rIns="0" bIns="0" rtlCol="0" anchor="ctr"/>
+          <a:lstStyle/>
+          <a:p>
+            <a:pPr indent="0" marL="0">
+              <a:buNone/>
+            </a:pPr>
+            <a:r>
+              <a:rPr lang="en-US" sz="1300" b="1" dirty="0">
+                <a:solidFill>
+                  <a:srgbClr val="0A1940"/>
+                </a:solidFill>
+                <a:latin typeface="Georgia" pitchFamily="34" charset="0"/>
+                <a:ea typeface="Georgia" pitchFamily="34" charset="-122"/>
+                <a:cs typeface="Georgia" pitchFamily="34" charset="-120"/>
+              </a:rPr>
+              <a:t>Tratamento no L1</a:t>
+            </a:r>
+            <a:endParaRPr lang="en-US" sz="1300" dirty="0"/>
+          </a:p>
+        </p:txBody>
+      </p:sp>
+      <p:sp>
+        <p:nvSpPr>
+          <p:cNvPr id="32" name="Text 30"/>
+          <p:cNvSpPr/>
+          <p:nvPr/>
+        </p:nvSpPr>
+        <p:spPr>
+          <a:xfrm>
+            <a:off x="3593592" y="4498848"/>
+            <a:ext cx="2313432" cy="502920"/>
+          </a:xfrm>
+          <a:prstGeom prst="rect">
+            <a:avLst/>
+          </a:prstGeom>
+          <a:noFill/>
+          <a:ln/>
+        </p:spPr>
+        <p:txBody>
+          <a:bodyPr wrap="square" lIns="0" tIns="0" rIns="0" bIns="0" rtlCol="0" anchor="ctr"/>
+          <a:lstStyle/>
+          <a:p>
+            <a:pPr indent="0" marL="0">
+              <a:buNone/>
+            </a:pPr>
+            <a:r>
+              <a:rPr lang="en-US" sz="1000" dirty="0">
+                <a:solidFill>
+                  <a:srgbClr val="1E293B"/>
+                </a:solidFill>
+                <a:latin typeface="Calibri" pitchFamily="34" charset="0"/>
+                <a:ea typeface="Calibri" pitchFamily="34" charset="-122"/>
+                <a:cs typeface="Calibri" pitchFamily="34" charset="-120"/>
+              </a:rPr>
+              <a:t>RPA cadastra pelo advogado</a:t>
+            </a:r>
+            <a:endParaRPr lang="en-US" sz="1000" dirty="0"/>
+          </a:p>
+        </p:txBody>
+      </p:sp>
+      <p:sp>
+        <p:nvSpPr>
+          <p:cNvPr id="33" name="Shape 31"/>
+          <p:cNvSpPr/>
+          <p:nvPr/>
+        </p:nvSpPr>
+        <p:spPr>
+          <a:xfrm>
+            <a:off x="3438144" y="5138928"/>
+            <a:ext cx="2468880" cy="1234440"/>
+          </a:xfrm>
+          <a:prstGeom prst="rect">
+            <a:avLst/>
+          </a:prstGeom>
+          <a:solidFill>
+            <a:srgbClr val="F4F6FB"/>
+          </a:solidFill>
+          <a:ln w="5080">
+            <a:solidFill>
+              <a:srgbClr val="E2E8F0"/>
+            </a:solidFill>
+            <a:prstDash val="solid"/>
+          </a:ln>
+        </p:spPr>
+      </p:sp>
+      <p:sp>
+        <p:nvSpPr>
+          <p:cNvPr id="34" name="Shape 32"/>
+          <p:cNvSpPr/>
+          <p:nvPr/>
+        </p:nvSpPr>
+        <p:spPr>
+          <a:xfrm>
+            <a:off x="3438144" y="5138928"/>
+            <a:ext cx="73152" cy="1234440"/>
+          </a:xfrm>
+          <a:prstGeom prst="rect">
+            <a:avLst/>
+          </a:prstGeom>
+          <a:solidFill>
+            <a:srgbClr val="0A1940"/>
+          </a:solidFill>
+          <a:ln w="12700">
+            <a:solidFill>
+              <a:srgbClr val="0A1940"/>
+            </a:solidFill>
+            <a:prstDash val="solid"/>
+          </a:ln>
+        </p:spPr>
+      </p:sp>
+      <p:sp>
+        <p:nvSpPr>
+          <p:cNvPr id="35" name="Text 33"/>
+          <p:cNvSpPr/>
+          <p:nvPr/>
+        </p:nvSpPr>
+        <p:spPr>
+          <a:xfrm>
+            <a:off x="3593592" y="5303520"/>
+            <a:ext cx="2313432" cy="457200"/>
+          </a:xfrm>
+          <a:prstGeom prst="rect">
+            <a:avLst/>
+          </a:prstGeom>
+          <a:noFill/>
+          <a:ln/>
+        </p:spPr>
+        <p:txBody>
+          <a:bodyPr wrap="square" lIns="0" tIns="0" rIns="0" bIns="0" rtlCol="0" anchor="ctr"/>
+          <a:lstStyle/>
+          <a:p>
+            <a:pPr indent="0" marL="0">
+              <a:buNone/>
+            </a:pPr>
+            <a:r>
+              <a:rPr lang="en-US" sz="1300" b="1" dirty="0">
+                <a:solidFill>
+                  <a:srgbClr val="0A1940"/>
+                </a:solidFill>
+                <a:latin typeface="Georgia" pitchFamily="34" charset="0"/>
+                <a:ea typeface="Georgia" pitchFamily="34" charset="-122"/>
+                <a:cs typeface="Georgia" pitchFamily="34" charset="-120"/>
+              </a:rPr>
+              <a:t>Criação em Lote</a:t>
+            </a:r>
+            <a:endParaRPr lang="en-US" sz="1300" dirty="0"/>
+          </a:p>
+        </p:txBody>
+      </p:sp>
+      <p:sp>
+        <p:nvSpPr>
+          <p:cNvPr id="36" name="Text 34"/>
+          <p:cNvSpPr/>
+          <p:nvPr/>
+        </p:nvSpPr>
+        <p:spPr>
+          <a:xfrm>
+            <a:off x="3593592" y="5779008"/>
+            <a:ext cx="2313432" cy="502920"/>
+          </a:xfrm>
+          <a:prstGeom prst="rect">
+            <a:avLst/>
+          </a:prstGeom>
+          <a:noFill/>
+          <a:ln/>
+        </p:spPr>
+        <p:txBody>
+          <a:bodyPr wrap="square" lIns="0" tIns="0" rIns="0" bIns="0" rtlCol="0" anchor="ctr"/>
+          <a:lstStyle/>
+          <a:p>
+            <a:pPr indent="0" marL="0">
+              <a:buNone/>
+            </a:pPr>
+            <a:r>
+              <a:rPr lang="en-US" sz="1000" dirty="0">
+                <a:solidFill>
+                  <a:srgbClr val="1E293B"/>
+                </a:solidFill>
+                <a:latin typeface="Calibri" pitchFamily="34" charset="0"/>
+                <a:ea typeface="Calibri" pitchFamily="34" charset="-122"/>
+                <a:cs typeface="Calibri" pitchFamily="34" charset="-120"/>
+              </a:rPr>
+              <a:t>Milhares de tarefas por execução</a:t>
+            </a:r>
+            <a:endParaRPr lang="en-US" sz="1000" dirty="0"/>
+          </a:p>
+        </p:txBody>
+      </p:sp>
+      <p:sp>
+        <p:nvSpPr>
+          <p:cNvPr id="37" name="Shape 35"/>
+          <p:cNvSpPr/>
+          <p:nvPr/>
+        </p:nvSpPr>
+        <p:spPr>
+          <a:xfrm>
+            <a:off x="6144768" y="1691640"/>
+            <a:ext cx="2743200" cy="4709160"/>
           </a:xfrm>
           <a:prstGeom prst="rect">
             <a:avLst/>
@@ -11174,62 +11894,38 @@
       </p:sp>
       <p:sp>
         <p:nvSpPr>
-          <p:cNvPr id="16" name="Shape 12"/>
-          <p:cNvSpPr/>
-          <p:nvPr/>
-        </p:nvSpPr>
-        <p:spPr>
-          <a:xfrm>
-            <a:off x="6163056" y="1737360"/>
-            <a:ext cx="2743200" cy="73152"/>
+          <p:cNvPr id="38" name="Shape 36"/>
+          <p:cNvSpPr/>
+          <p:nvPr/>
+        </p:nvSpPr>
+        <p:spPr>
+          <a:xfrm>
+            <a:off x="6144768" y="1691640"/>
+            <a:ext cx="2743200" cy="777240"/>
           </a:xfrm>
           <a:prstGeom prst="rect">
             <a:avLst/>
           </a:prstGeom>
           <a:solidFill>
-            <a:srgbClr val="0A1940"/>
+            <a:srgbClr val="0B7A79"/>
           </a:solidFill>
           <a:ln w="12700">
             <a:solidFill>
-              <a:srgbClr val="0A1940"/>
+              <a:srgbClr val="0B7A79"/>
             </a:solidFill>
             <a:prstDash val="solid"/>
           </a:ln>
         </p:spPr>
       </p:sp>
-      <p:pic>
-        <p:nvPicPr>
-          <p:cNvPr id="17" name="Image 2" descr="preencoded.png">    </p:cNvPr>
-          <p:cNvPicPr>
-            <a:picLocks noChangeAspect="1"/>
-          </p:cNvPicPr>
-          <p:nvPr/>
-        </p:nvPicPr>
-        <p:blipFill>
-          <a:blip r:embed="rId3"/>
-          <a:stretch>
-            <a:fillRect/>
-          </a:stretch>
-        </p:blipFill>
-        <p:spPr>
-          <a:xfrm>
-            <a:off x="6437376" y="2103120"/>
-            <a:ext cx="548640" cy="548640"/>
-          </a:xfrm>
-          <a:prstGeom prst="rect">
-            <a:avLst/>
-          </a:prstGeom>
-        </p:spPr>
-      </p:pic>
-      <p:sp>
-        <p:nvSpPr>
-          <p:cNvPr id="18" name="Text 13"/>
-          <p:cNvSpPr/>
-          <p:nvPr/>
-        </p:nvSpPr>
-        <p:spPr>
-          <a:xfrm>
-            <a:off x="6391656" y="2788920"/>
+      <p:sp>
+        <p:nvSpPr>
+          <p:cNvPr id="39" name="Text 37"/>
+          <p:cNvSpPr/>
+          <p:nvPr/>
+        </p:nvSpPr>
+        <p:spPr>
+          <a:xfrm>
+            <a:off x="6373368" y="1801368"/>
             <a:ext cx="2286000" cy="365760"/>
           </a:xfrm>
           <a:prstGeom prst="rect">
@@ -11246,15 +11942,15 @@
               <a:buNone/>
             </a:pPr>
             <a:r>
-              <a:rPr lang="en-US" sz="1500" b="1" dirty="0">
-                <a:solidFill>
-                  <a:srgbClr val="0A1940"/>
+              <a:rPr lang="en-US" sz="1500" b="1" spc="400" kern="0" dirty="0">
+                <a:solidFill>
+                  <a:srgbClr val="FFFFFF"/>
                 </a:solidFill>
                 <a:latin typeface="Georgia" pitchFamily="34" charset="0"/>
                 <a:ea typeface="Georgia" pitchFamily="34" charset="-122"/>
                 <a:cs typeface="Georgia" pitchFamily="34" charset="-120"/>
               </a:rPr>
-              <a:t>Tratamento de publicações</a:t>
+              <a:t>INTELIGÊNCIA</a:t>
             </a:r>
             <a:endParaRPr lang="en-US" sz="1500" dirty="0"/>
           </a:p>
@@ -11262,30 +11958,158 @@
       </p:sp>
       <p:sp>
         <p:nvSpPr>
-          <p:cNvPr id="19" name="Text 14"/>
-          <p:cNvSpPr/>
-          <p:nvPr/>
-        </p:nvSpPr>
-        <p:spPr>
-          <a:xfrm>
-            <a:off x="6391656" y="3108960"/>
-            <a:ext cx="2286000" cy="777240"/>
-          </a:xfrm>
-          <a:prstGeom prst="rect">
-            <a:avLst/>
-          </a:prstGeom>
-          <a:noFill/>
-          <a:ln/>
-        </p:spPr>
-        <p:txBody>
-          <a:bodyPr wrap="square" lIns="0" tIns="0" rIns="0" bIns="0" rtlCol="0" anchor="ctr"/>
-          <a:lstStyle/>
-          <a:p>
-            <a:pPr indent="0" marL="0">
-              <a:buNone/>
-            </a:pPr>
-            <a:r>
-              <a:rPr lang="en-US" sz="1100" dirty="0">
+          <p:cNvPr id="40" name="Text 38"/>
+          <p:cNvSpPr/>
+          <p:nvPr/>
+        </p:nvSpPr>
+        <p:spPr>
+          <a:xfrm>
+            <a:off x="6373368" y="2148840"/>
+            <a:ext cx="2286000" cy="274320"/>
+          </a:xfrm>
+          <a:prstGeom prst="rect">
+            <a:avLst/>
+          </a:prstGeom>
+          <a:noFill/>
+          <a:ln/>
+        </p:spPr>
+        <p:txBody>
+          <a:bodyPr wrap="square" lIns="0" tIns="0" rIns="0" bIns="0" rtlCol="0" anchor="ctr"/>
+          <a:lstStyle/>
+          <a:p>
+            <a:pPr indent="0" marL="0">
+              <a:buNone/>
+            </a:pPr>
+            <a:r>
+              <a:rPr lang="en-US" sz="1000" i="1" dirty="0">
+                <a:solidFill>
+                  <a:srgbClr val="DCE6F7"/>
+                </a:solidFill>
+                <a:latin typeface="Calibri" pitchFamily="34" charset="0"/>
+                <a:ea typeface="Calibri" pitchFamily="34" charset="-122"/>
+                <a:cs typeface="Calibri" pitchFamily="34" charset="-120"/>
+              </a:rPr>
+              <a:t>O que a plataforma decide</a:t>
+            </a:r>
+            <a:endParaRPr lang="en-US" sz="1000" dirty="0"/>
+          </a:p>
+        </p:txBody>
+      </p:sp>
+      <p:sp>
+        <p:nvSpPr>
+          <p:cNvPr id="41" name="Shape 39"/>
+          <p:cNvSpPr/>
+          <p:nvPr/>
+        </p:nvSpPr>
+        <p:spPr>
+          <a:xfrm>
+            <a:off x="6281928" y="2578608"/>
+            <a:ext cx="2468880" cy="1234440"/>
+          </a:xfrm>
+          <a:prstGeom prst="rect">
+            <a:avLst/>
+          </a:prstGeom>
+          <a:solidFill>
+            <a:srgbClr val="F4F6FB"/>
+          </a:solidFill>
+          <a:ln w="5080">
+            <a:solidFill>
+              <a:srgbClr val="E2E8F0"/>
+            </a:solidFill>
+            <a:prstDash val="solid"/>
+          </a:ln>
+        </p:spPr>
+      </p:sp>
+      <p:sp>
+        <p:nvSpPr>
+          <p:cNvPr id="42" name="Shape 40"/>
+          <p:cNvSpPr/>
+          <p:nvPr/>
+        </p:nvSpPr>
+        <p:spPr>
+          <a:xfrm>
+            <a:off x="6281928" y="2578608"/>
+            <a:ext cx="73152" cy="1234440"/>
+          </a:xfrm>
+          <a:prstGeom prst="rect">
+            <a:avLst/>
+          </a:prstGeom>
+          <a:solidFill>
+            <a:srgbClr val="0B7A79"/>
+          </a:solidFill>
+          <a:ln w="12700">
+            <a:solidFill>
+              <a:srgbClr val="0B7A79"/>
+            </a:solidFill>
+            <a:prstDash val="solid"/>
+          </a:ln>
+        </p:spPr>
+      </p:sp>
+      <p:sp>
+        <p:nvSpPr>
+          <p:cNvPr id="43" name="Text 41"/>
+          <p:cNvSpPr/>
+          <p:nvPr/>
+        </p:nvSpPr>
+        <p:spPr>
+          <a:xfrm>
+            <a:off x="6437376" y="2743200"/>
+            <a:ext cx="2313432" cy="457200"/>
+          </a:xfrm>
+          <a:prstGeom prst="rect">
+            <a:avLst/>
+          </a:prstGeom>
+          <a:noFill/>
+          <a:ln/>
+        </p:spPr>
+        <p:txBody>
+          <a:bodyPr wrap="square" lIns="0" tIns="0" rIns="0" bIns="0" rtlCol="0" anchor="ctr"/>
+          <a:lstStyle/>
+          <a:p>
+            <a:pPr indent="0" marL="0">
+              <a:buNone/>
+            </a:pPr>
+            <a:r>
+              <a:rPr lang="en-US" sz="1300" b="1" dirty="0">
+                <a:solidFill>
+                  <a:srgbClr val="0A1940"/>
+                </a:solidFill>
+                <a:latin typeface="Georgia" pitchFamily="34" charset="0"/>
+                <a:ea typeface="Georgia" pitchFamily="34" charset="-122"/>
+                <a:cs typeface="Georgia" pitchFamily="34" charset="-120"/>
+              </a:rPr>
+              <a:t>Monitoramento Processual</a:t>
+            </a:r>
+            <a:endParaRPr lang="en-US" sz="1300" dirty="0"/>
+          </a:p>
+        </p:txBody>
+      </p:sp>
+      <p:sp>
+        <p:nvSpPr>
+          <p:cNvPr id="44" name="Text 42"/>
+          <p:cNvSpPr/>
+          <p:nvPr/>
+        </p:nvSpPr>
+        <p:spPr>
+          <a:xfrm>
+            <a:off x="6437376" y="3218688"/>
+            <a:ext cx="2313432" cy="502920"/>
+          </a:xfrm>
+          <a:prstGeom prst="rect">
+            <a:avLst/>
+          </a:prstGeom>
+          <a:noFill/>
+          <a:ln/>
+        </p:spPr>
+        <p:txBody>
+          <a:bodyPr wrap="square" lIns="0" tIns="0" rIns="0" bIns="0" rtlCol="0" anchor="ctr"/>
+          <a:lstStyle/>
+          <a:p>
+            <a:pPr indent="0" marL="0">
+              <a:buNone/>
+            </a:pPr>
+            <a:r>
+              <a:rPr lang="en-US" sz="1000" dirty="0">
                 <a:solidFill>
                   <a:srgbClr val="1E293B"/>
                 </a:solidFill>
@@ -11293,22 +12117,278 @@
                 <a:ea typeface="Calibri" pitchFamily="34" charset="-122"/>
                 <a:cs typeface="Calibri" pitchFamily="34" charset="-120"/>
               </a:rPr>
-              <a:t>RPA cadastra a tarefa no Legal One pelo advogado.</a:t>
-            </a:r>
-            <a:endParaRPr lang="en-US" sz="1100" dirty="0"/>
-          </a:p>
-        </p:txBody>
-      </p:sp>
-      <p:sp>
-        <p:nvSpPr>
-          <p:cNvPr id="20" name="Shape 15"/>
-          <p:cNvSpPr/>
-          <p:nvPr/>
-        </p:nvSpPr>
-        <p:spPr>
-          <a:xfrm>
-            <a:off x="9043416" y="1737360"/>
-            <a:ext cx="2743200" cy="2194560"/>
+              <a:t>DataJud + régua 7 níveis</a:t>
+            </a:r>
+            <a:endParaRPr lang="en-US" sz="1000" dirty="0"/>
+          </a:p>
+        </p:txBody>
+      </p:sp>
+      <p:sp>
+        <p:nvSpPr>
+          <p:cNvPr id="45" name="Shape 43"/>
+          <p:cNvSpPr/>
+          <p:nvPr/>
+        </p:nvSpPr>
+        <p:spPr>
+          <a:xfrm>
+            <a:off x="6281928" y="3858768"/>
+            <a:ext cx="2468880" cy="1234440"/>
+          </a:xfrm>
+          <a:prstGeom prst="rect">
+            <a:avLst/>
+          </a:prstGeom>
+          <a:solidFill>
+            <a:srgbClr val="F4F6FB"/>
+          </a:solidFill>
+          <a:ln w="5080">
+            <a:solidFill>
+              <a:srgbClr val="E2E8F0"/>
+            </a:solidFill>
+            <a:prstDash val="solid"/>
+          </a:ln>
+        </p:spPr>
+      </p:sp>
+      <p:sp>
+        <p:nvSpPr>
+          <p:cNvPr id="46" name="Shape 44"/>
+          <p:cNvSpPr/>
+          <p:nvPr/>
+        </p:nvSpPr>
+        <p:spPr>
+          <a:xfrm>
+            <a:off x="6281928" y="3858768"/>
+            <a:ext cx="73152" cy="1234440"/>
+          </a:xfrm>
+          <a:prstGeom prst="rect">
+            <a:avLst/>
+          </a:prstGeom>
+          <a:solidFill>
+            <a:srgbClr val="0B7A79"/>
+          </a:solidFill>
+          <a:ln w="12700">
+            <a:solidFill>
+              <a:srgbClr val="0B7A79"/>
+            </a:solidFill>
+            <a:prstDash val="solid"/>
+          </a:ln>
+        </p:spPr>
+      </p:sp>
+      <p:sp>
+        <p:nvSpPr>
+          <p:cNvPr id="47" name="Text 45"/>
+          <p:cNvSpPr/>
+          <p:nvPr/>
+        </p:nvSpPr>
+        <p:spPr>
+          <a:xfrm>
+            <a:off x="6437376" y="4023360"/>
+            <a:ext cx="2313432" cy="457200"/>
+          </a:xfrm>
+          <a:prstGeom prst="rect">
+            <a:avLst/>
+          </a:prstGeom>
+          <a:noFill/>
+          <a:ln/>
+        </p:spPr>
+        <p:txBody>
+          <a:bodyPr wrap="square" lIns="0" tIns="0" rIns="0" bIns="0" rtlCol="0" anchor="ctr"/>
+          <a:lstStyle/>
+          <a:p>
+            <a:pPr indent="0" marL="0">
+              <a:buNone/>
+            </a:pPr>
+            <a:r>
+              <a:rPr lang="en-US" sz="1300" b="1" dirty="0">
+                <a:solidFill>
+                  <a:srgbClr val="0A1940"/>
+                </a:solidFill>
+                <a:latin typeface="Georgia" pitchFamily="34" charset="0"/>
+                <a:ea typeface="Georgia" pitchFamily="34" charset="-122"/>
+                <a:cs typeface="Georgia" pitchFamily="34" charset="-120"/>
+              </a:rPr>
+              <a:t>Análise Recursal</a:t>
+            </a:r>
+            <a:endParaRPr lang="en-US" sz="1300" dirty="0"/>
+          </a:p>
+        </p:txBody>
+      </p:sp>
+      <p:sp>
+        <p:nvSpPr>
+          <p:cNvPr id="48" name="Text 46"/>
+          <p:cNvSpPr/>
+          <p:nvPr/>
+        </p:nvSpPr>
+        <p:spPr>
+          <a:xfrm>
+            <a:off x="6437376" y="4498848"/>
+            <a:ext cx="2313432" cy="502920"/>
+          </a:xfrm>
+          <a:prstGeom prst="rect">
+            <a:avLst/>
+          </a:prstGeom>
+          <a:noFill/>
+          <a:ln/>
+        </p:spPr>
+        <p:txBody>
+          <a:bodyPr wrap="square" lIns="0" tIns="0" rIns="0" bIns="0" rtlCol="0" anchor="ctr"/>
+          <a:lstStyle/>
+          <a:p>
+            <a:pPr indent="0" marL="0">
+              <a:buNone/>
+            </a:pPr>
+            <a:r>
+              <a:rPr lang="en-US" sz="1000" dirty="0">
+                <a:solidFill>
+                  <a:srgbClr val="1E293B"/>
+                </a:solidFill>
+                <a:latin typeface="Calibri" pitchFamily="34" charset="0"/>
+                <a:ea typeface="Calibri" pitchFamily="34" charset="-122"/>
+                <a:cs typeface="Calibri" pitchFamily="34" charset="-120"/>
+              </a:rPr>
+              <a:t>Sonnet + custas dos 27 TJs</a:t>
+            </a:r>
+            <a:endParaRPr lang="en-US" sz="1000" dirty="0"/>
+          </a:p>
+        </p:txBody>
+      </p:sp>
+      <p:sp>
+        <p:nvSpPr>
+          <p:cNvPr id="49" name="Shape 47"/>
+          <p:cNvSpPr/>
+          <p:nvPr/>
+        </p:nvSpPr>
+        <p:spPr>
+          <a:xfrm>
+            <a:off x="6281928" y="5138928"/>
+            <a:ext cx="2468880" cy="1234440"/>
+          </a:xfrm>
+          <a:prstGeom prst="rect">
+            <a:avLst/>
+          </a:prstGeom>
+          <a:solidFill>
+            <a:srgbClr val="F4F6FB"/>
+          </a:solidFill>
+          <a:ln w="5080">
+            <a:solidFill>
+              <a:srgbClr val="E2E8F0"/>
+            </a:solidFill>
+            <a:prstDash val="solid"/>
+          </a:ln>
+        </p:spPr>
+      </p:sp>
+      <p:sp>
+        <p:nvSpPr>
+          <p:cNvPr id="50" name="Shape 48"/>
+          <p:cNvSpPr/>
+          <p:nvPr/>
+        </p:nvSpPr>
+        <p:spPr>
+          <a:xfrm>
+            <a:off x="6281928" y="5138928"/>
+            <a:ext cx="73152" cy="1234440"/>
+          </a:xfrm>
+          <a:prstGeom prst="rect">
+            <a:avLst/>
+          </a:prstGeom>
+          <a:solidFill>
+            <a:srgbClr val="0B7A79"/>
+          </a:solidFill>
+          <a:ln w="12700">
+            <a:solidFill>
+              <a:srgbClr val="0B7A79"/>
+            </a:solidFill>
+            <a:prstDash val="solid"/>
+          </a:ln>
+        </p:spPr>
+      </p:sp>
+      <p:sp>
+        <p:nvSpPr>
+          <p:cNvPr id="51" name="Text 49"/>
+          <p:cNvSpPr/>
+          <p:nvPr/>
+        </p:nvSpPr>
+        <p:spPr>
+          <a:xfrm>
+            <a:off x="6437376" y="5303520"/>
+            <a:ext cx="2313432" cy="457200"/>
+          </a:xfrm>
+          <a:prstGeom prst="rect">
+            <a:avLst/>
+          </a:prstGeom>
+          <a:noFill/>
+          <a:ln/>
+        </p:spPr>
+        <p:txBody>
+          <a:bodyPr wrap="square" lIns="0" tIns="0" rIns="0" bIns="0" rtlCol="0" anchor="ctr"/>
+          <a:lstStyle/>
+          <a:p>
+            <a:pPr indent="0" marL="0">
+              <a:buNone/>
+            </a:pPr>
+            <a:r>
+              <a:rPr lang="en-US" sz="1300" b="1" dirty="0">
+                <a:solidFill>
+                  <a:srgbClr val="0A1940"/>
+                </a:solidFill>
+                <a:latin typeface="Georgia" pitchFamily="34" charset="0"/>
+                <a:ea typeface="Georgia" pitchFamily="34" charset="-122"/>
+                <a:cs typeface="Georgia" pitchFamily="34" charset="-120"/>
+              </a:rPr>
+              <a:t>Automações Agendadas</a:t>
+            </a:r>
+            <a:endParaRPr lang="en-US" sz="1300" dirty="0"/>
+          </a:p>
+        </p:txBody>
+      </p:sp>
+      <p:sp>
+        <p:nvSpPr>
+          <p:cNvPr id="52" name="Text 50"/>
+          <p:cNvSpPr/>
+          <p:nvPr/>
+        </p:nvSpPr>
+        <p:spPr>
+          <a:xfrm>
+            <a:off x="6437376" y="5779008"/>
+            <a:ext cx="2313432" cy="502920"/>
+          </a:xfrm>
+          <a:prstGeom prst="rect">
+            <a:avLst/>
+          </a:prstGeom>
+          <a:noFill/>
+          <a:ln/>
+        </p:spPr>
+        <p:txBody>
+          <a:bodyPr wrap="square" lIns="0" tIns="0" rIns="0" bIns="0" rtlCol="0" anchor="ctr"/>
+          <a:lstStyle/>
+          <a:p>
+            <a:pPr indent="0" marL="0">
+              <a:buNone/>
+            </a:pPr>
+            <a:r>
+              <a:rPr lang="en-US" sz="1000" dirty="0">
+                <a:solidFill>
+                  <a:srgbClr val="1E293B"/>
+                </a:solidFill>
+                <a:latin typeface="Calibri" pitchFamily="34" charset="0"/>
+                <a:ea typeface="Calibri" pitchFamily="34" charset="-122"/>
+                <a:cs typeface="Calibri" pitchFamily="34" charset="-120"/>
+              </a:rPr>
+              <a:t>APScheduler em alta disponib.</a:t>
+            </a:r>
+            <a:endParaRPr lang="en-US" sz="1000" dirty="0"/>
+          </a:p>
+        </p:txBody>
+      </p:sp>
+      <p:sp>
+        <p:nvSpPr>
+          <p:cNvPr id="53" name="Shape 51"/>
+          <p:cNvSpPr/>
+          <p:nvPr/>
+        </p:nvSpPr>
+        <p:spPr>
+          <a:xfrm>
+            <a:off x="8988552" y="1691640"/>
+            <a:ext cx="2743200" cy="4709160"/>
           </a:xfrm>
           <a:prstGeom prst="rect">
             <a:avLst/>
@@ -11333,62 +12413,38 @@
       </p:sp>
       <p:sp>
         <p:nvSpPr>
-          <p:cNvPr id="21" name="Shape 16"/>
-          <p:cNvSpPr/>
-          <p:nvPr/>
-        </p:nvSpPr>
-        <p:spPr>
-          <a:xfrm>
-            <a:off x="9043416" y="1737360"/>
-            <a:ext cx="2743200" cy="73152"/>
+          <p:cNvPr id="54" name="Shape 52"/>
+          <p:cNvSpPr/>
+          <p:nvPr/>
+        </p:nvSpPr>
+        <p:spPr>
+          <a:xfrm>
+            <a:off x="8988552" y="1691640"/>
+            <a:ext cx="2743200" cy="777240"/>
           </a:xfrm>
           <a:prstGeom prst="rect">
             <a:avLst/>
           </a:prstGeom>
           <a:solidFill>
-            <a:srgbClr val="0A1940"/>
+            <a:srgbClr val="1558CC"/>
           </a:solidFill>
           <a:ln w="12700">
             <a:solidFill>
-              <a:srgbClr val="0A1940"/>
+              <a:srgbClr val="1558CC"/>
             </a:solidFill>
             <a:prstDash val="solid"/>
           </a:ln>
         </p:spPr>
       </p:sp>
-      <p:pic>
-        <p:nvPicPr>
-          <p:cNvPr id="22" name="Image 3" descr="preencoded.png">    </p:cNvPr>
-          <p:cNvPicPr>
-            <a:picLocks noChangeAspect="1"/>
-          </p:cNvPicPr>
-          <p:nvPr/>
-        </p:nvPicPr>
-        <p:blipFill>
-          <a:blip r:embed="rId4"/>
-          <a:stretch>
-            <a:fillRect/>
-          </a:stretch>
-        </p:blipFill>
-        <p:spPr>
-          <a:xfrm>
-            <a:off x="9317736" y="2103120"/>
-            <a:ext cx="548640" cy="548640"/>
-          </a:xfrm>
-          <a:prstGeom prst="rect">
-            <a:avLst/>
-          </a:prstGeom>
-        </p:spPr>
-      </p:pic>
-      <p:sp>
-        <p:nvSpPr>
-          <p:cNvPr id="23" name="Text 17"/>
-          <p:cNvSpPr/>
-          <p:nvPr/>
-        </p:nvSpPr>
-        <p:spPr>
-          <a:xfrm>
-            <a:off x="9272016" y="2788920"/>
+      <p:sp>
+        <p:nvSpPr>
+          <p:cNvPr id="55" name="Text 53"/>
+          <p:cNvSpPr/>
+          <p:nvPr/>
+        </p:nvSpPr>
+        <p:spPr>
+          <a:xfrm>
+            <a:off x="9217152" y="1801368"/>
             <a:ext cx="2286000" cy="365760"/>
           </a:xfrm>
           <a:prstGeom prst="rect">
@@ -11405,15 +12461,15 @@
               <a:buNone/>
             </a:pPr>
             <a:r>
-              <a:rPr lang="en-US" sz="1500" b="1" dirty="0">
-                <a:solidFill>
-                  <a:srgbClr val="0A1940"/>
+              <a:rPr lang="en-US" sz="1500" b="1" spc="400" kern="0" dirty="0">
+                <a:solidFill>
+                  <a:srgbClr val="FFFFFF"/>
                 </a:solidFill>
                 <a:latin typeface="Georgia" pitchFamily="34" charset="0"/>
                 <a:ea typeface="Georgia" pitchFamily="34" charset="-122"/>
                 <a:cs typeface="Georgia" pitchFamily="34" charset="-120"/>
               </a:rPr>
-              <a:t>Prazos Iniciais</a:t>
+              <a:t>GESTÃO</a:t>
             </a:r>
             <a:endParaRPr lang="en-US" sz="1500" dirty="0"/>
           </a:p>
@@ -11421,150 +12477,119 @@
       </p:sp>
       <p:sp>
         <p:nvSpPr>
-          <p:cNvPr id="24" name="Text 18"/>
-          <p:cNvSpPr/>
-          <p:nvPr/>
-        </p:nvSpPr>
-        <p:spPr>
-          <a:xfrm>
-            <a:off x="9272016" y="3108960"/>
-            <a:ext cx="2286000" cy="777240"/>
-          </a:xfrm>
-          <a:prstGeom prst="rect">
-            <a:avLst/>
-          </a:prstGeom>
-          <a:noFill/>
-          <a:ln/>
-        </p:spPr>
-        <p:txBody>
-          <a:bodyPr wrap="square" lIns="0" tIns="0" rIns="0" bIns="0" rtlCol="0" anchor="ctr"/>
-          <a:lstStyle/>
-          <a:p>
-            <a:pPr indent="0" marL="0">
-              <a:buNone/>
-            </a:pPr>
-            <a:r>
-              <a:rPr lang="en-US" sz="1100" dirty="0">
-                <a:solidFill>
-                  <a:srgbClr val="1E293B"/>
-                </a:solidFill>
-                <a:latin typeface="Calibri" pitchFamily="34" charset="0"/>
-                <a:ea typeface="Calibri" pitchFamily="34" charset="-122"/>
-                <a:cs typeface="Calibri" pitchFamily="34" charset="-120"/>
-              </a:rPr>
-              <a:t>Intake da PI, classificação IA e prazo fatal por CPC 25.</a:t>
-            </a:r>
-            <a:endParaRPr lang="en-US" sz="1100" dirty="0"/>
-          </a:p>
-        </p:txBody>
-      </p:sp>
-      <p:sp>
-        <p:nvSpPr>
-          <p:cNvPr id="25" name="Shape 19"/>
-          <p:cNvSpPr/>
-          <p:nvPr/>
-        </p:nvSpPr>
-        <p:spPr>
-          <a:xfrm>
-            <a:off x="402336" y="4069080"/>
-            <a:ext cx="2743200" cy="2194560"/>
+          <p:cNvPr id="56" name="Text 54"/>
+          <p:cNvSpPr/>
+          <p:nvPr/>
+        </p:nvSpPr>
+        <p:spPr>
+          <a:xfrm>
+            <a:off x="9217152" y="2148840"/>
+            <a:ext cx="2286000" cy="274320"/>
+          </a:xfrm>
+          <a:prstGeom prst="rect">
+            <a:avLst/>
+          </a:prstGeom>
+          <a:noFill/>
+          <a:ln/>
+        </p:spPr>
+        <p:txBody>
+          <a:bodyPr wrap="square" lIns="0" tIns="0" rIns="0" bIns="0" rtlCol="0" anchor="ctr"/>
+          <a:lstStyle/>
+          <a:p>
+            <a:pPr indent="0" marL="0">
+              <a:buNone/>
+            </a:pPr>
+            <a:r>
+              <a:rPr lang="en-US" sz="1000" i="1" dirty="0">
+                <a:solidFill>
+                  <a:srgbClr val="DCE6F7"/>
+                </a:solidFill>
+                <a:latin typeface="Calibri" pitchFamily="34" charset="0"/>
+                <a:ea typeface="Calibri" pitchFamily="34" charset="-122"/>
+                <a:cs typeface="Calibri" pitchFamily="34" charset="-120"/>
+              </a:rPr>
+              <a:t>Como o escritório se enxerga</a:t>
+            </a:r>
+            <a:endParaRPr lang="en-US" sz="1000" dirty="0"/>
+          </a:p>
+        </p:txBody>
+      </p:sp>
+      <p:sp>
+        <p:nvSpPr>
+          <p:cNvPr id="57" name="Shape 55"/>
+          <p:cNvSpPr/>
+          <p:nvPr/>
+        </p:nvSpPr>
+        <p:spPr>
+          <a:xfrm>
+            <a:off x="9125712" y="2578608"/>
+            <a:ext cx="2468880" cy="1234440"/>
           </a:xfrm>
           <a:prstGeom prst="rect">
             <a:avLst/>
           </a:prstGeom>
           <a:solidFill>
-            <a:srgbClr val="FFFFFF"/>
+            <a:srgbClr val="F4F6FB"/>
           </a:solidFill>
-          <a:ln w="6350">
+          <a:ln w="5080">
             <a:solidFill>
               <a:srgbClr val="E2E8F0"/>
             </a:solidFill>
             <a:prstDash val="solid"/>
           </a:ln>
-          <a:effectLst>
-            <a:outerShdw sx="100000" sy="100000" kx="0" ky="0" algn="bl" rotWithShape="0" blurRad="127000" dist="38100" dir="5400000">
-              <a:srgbClr val="000000">
-                <a:alpha val="10000"/>
-              </a:srgbClr>
-            </a:outerShdw>
-          </a:effectLst>
-        </p:spPr>
-      </p:sp>
-      <p:sp>
-        <p:nvSpPr>
-          <p:cNvPr id="26" name="Shape 20"/>
-          <p:cNvSpPr/>
-          <p:nvPr/>
-        </p:nvSpPr>
-        <p:spPr>
-          <a:xfrm>
-            <a:off x="402336" y="4069080"/>
-            <a:ext cx="2743200" cy="73152"/>
+        </p:spPr>
+      </p:sp>
+      <p:sp>
+        <p:nvSpPr>
+          <p:cNvPr id="58" name="Shape 56"/>
+          <p:cNvSpPr/>
+          <p:nvPr/>
+        </p:nvSpPr>
+        <p:spPr>
+          <a:xfrm>
+            <a:off x="9125712" y="2578608"/>
+            <a:ext cx="73152" cy="1234440"/>
           </a:xfrm>
           <a:prstGeom prst="rect">
             <a:avLst/>
           </a:prstGeom>
           <a:solidFill>
-            <a:srgbClr val="0A1940"/>
+            <a:srgbClr val="1558CC"/>
           </a:solidFill>
           <a:ln w="12700">
             <a:solidFill>
-              <a:srgbClr val="0A1940"/>
+              <a:srgbClr val="1558CC"/>
             </a:solidFill>
             <a:prstDash val="solid"/>
           </a:ln>
         </p:spPr>
       </p:sp>
-      <p:pic>
-        <p:nvPicPr>
-          <p:cNvPr id="27" name="Image 4" descr="preencoded.png">    </p:cNvPr>
-          <p:cNvPicPr>
-            <a:picLocks noChangeAspect="1"/>
-          </p:cNvPicPr>
-          <p:nvPr/>
-        </p:nvPicPr>
-        <p:blipFill>
-          <a:blip r:embed="rId5"/>
-          <a:stretch>
-            <a:fillRect/>
-          </a:stretch>
-        </p:blipFill>
-        <p:spPr>
-          <a:xfrm>
-            <a:off x="676656" y="4434840"/>
-            <a:ext cx="548640" cy="548640"/>
-          </a:xfrm>
-          <a:prstGeom prst="rect">
-            <a:avLst/>
-          </a:prstGeom>
-        </p:spPr>
-      </p:pic>
-      <p:sp>
-        <p:nvSpPr>
-          <p:cNvPr id="28" name="Text 21"/>
-          <p:cNvSpPr/>
-          <p:nvPr/>
-        </p:nvSpPr>
-        <p:spPr>
-          <a:xfrm>
-            <a:off x="630936" y="5120640"/>
-            <a:ext cx="2286000" cy="365760"/>
-          </a:xfrm>
-          <a:prstGeom prst="rect">
-            <a:avLst/>
-          </a:prstGeom>
-          <a:noFill/>
-          <a:ln/>
-        </p:spPr>
-        <p:txBody>
-          <a:bodyPr wrap="square" lIns="0" tIns="0" rIns="0" bIns="0" rtlCol="0" anchor="ctr"/>
-          <a:lstStyle/>
-          <a:p>
-            <a:pPr indent="0" marL="0">
-              <a:buNone/>
-            </a:pPr>
-            <a:r>
-              <a:rPr lang="en-US" sz="1500" b="1" dirty="0">
+      <p:sp>
+        <p:nvSpPr>
+          <p:cNvPr id="59" name="Text 57"/>
+          <p:cNvSpPr/>
+          <p:nvPr/>
+        </p:nvSpPr>
+        <p:spPr>
+          <a:xfrm>
+            <a:off x="9281160" y="2743200"/>
+            <a:ext cx="2313432" cy="457200"/>
+          </a:xfrm>
+          <a:prstGeom prst="rect">
+            <a:avLst/>
+          </a:prstGeom>
+          <a:noFill/>
+          <a:ln/>
+        </p:spPr>
+        <p:txBody>
+          <a:bodyPr wrap="square" lIns="0" tIns="0" rIns="0" bIns="0" rtlCol="0" anchor="ctr"/>
+          <a:lstStyle/>
+          <a:p>
+            <a:pPr indent="0" marL="0">
+              <a:buNone/>
+            </a:pPr>
+            <a:r>
+              <a:rPr lang="en-US" sz="1300" b="1" dirty="0">
                 <a:solidFill>
                   <a:srgbClr val="0A1940"/>
                 </a:solidFill>
@@ -11572,38 +12597,38 @@
                 <a:ea typeface="Georgia" pitchFamily="34" charset="-122"/>
                 <a:cs typeface="Georgia" pitchFamily="34" charset="-120"/>
               </a:rPr>
-              <a:t>Monitoramento processual</a:t>
-            </a:r>
-            <a:endParaRPr lang="en-US" sz="1500" dirty="0"/>
-          </a:p>
-        </p:txBody>
-      </p:sp>
-      <p:sp>
-        <p:nvSpPr>
-          <p:cNvPr id="29" name="Text 22"/>
-          <p:cNvSpPr/>
-          <p:nvPr/>
-        </p:nvSpPr>
-        <p:spPr>
-          <a:xfrm>
-            <a:off x="630936" y="5440680"/>
-            <a:ext cx="2286000" cy="777240"/>
-          </a:xfrm>
-          <a:prstGeom prst="rect">
-            <a:avLst/>
-          </a:prstGeom>
-          <a:noFill/>
-          <a:ln/>
-        </p:spPr>
-        <p:txBody>
-          <a:bodyPr wrap="square" lIns="0" tIns="0" rIns="0" bIns="0" rtlCol="0" anchor="ctr"/>
-          <a:lstStyle/>
-          <a:p>
-            <a:pPr indent="0" marL="0">
-              <a:buNone/>
-            </a:pPr>
-            <a:r>
-              <a:rPr lang="en-US" sz="1100" dirty="0">
+              <a:t>Minha Equipe</a:t>
+            </a:r>
+            <a:endParaRPr lang="en-US" sz="1300" dirty="0"/>
+          </a:p>
+        </p:txBody>
+      </p:sp>
+      <p:sp>
+        <p:nvSpPr>
+          <p:cNvPr id="60" name="Text 58"/>
+          <p:cNvSpPr/>
+          <p:nvPr/>
+        </p:nvSpPr>
+        <p:spPr>
+          <a:xfrm>
+            <a:off x="9281160" y="3218688"/>
+            <a:ext cx="2313432" cy="502920"/>
+          </a:xfrm>
+          <a:prstGeom prst="rect">
+            <a:avLst/>
+          </a:prstGeom>
+          <a:noFill/>
+          <a:ln/>
+        </p:spPr>
+        <p:txBody>
+          <a:bodyPr wrap="square" lIns="0" tIns="0" rIns="0" bIns="0" rtlCol="0" anchor="ctr"/>
+          <a:lstStyle/>
+          <a:p>
+            <a:pPr indent="0" marL="0">
+              <a:buNone/>
+            </a:pPr>
+            <a:r>
+              <a:rPr lang="en-US" sz="1000" dirty="0">
                 <a:solidFill>
                   <a:srgbClr val="1E293B"/>
                 </a:solidFill>
@@ -11611,119 +12636,88 @@
                 <a:ea typeface="Calibri" pitchFamily="34" charset="-122"/>
                 <a:cs typeface="Calibri" pitchFamily="34" charset="-120"/>
               </a:rPr>
-              <a:t>DataJud e DJEN com régua de maturidade.</a:t>
-            </a:r>
-            <a:endParaRPr lang="en-US" sz="1100" dirty="0"/>
-          </a:p>
-        </p:txBody>
-      </p:sp>
-      <p:sp>
-        <p:nvSpPr>
-          <p:cNvPr id="30" name="Shape 23"/>
-          <p:cNvSpPr/>
-          <p:nvPr/>
-        </p:nvSpPr>
-        <p:spPr>
-          <a:xfrm>
-            <a:off x="3282696" y="4069080"/>
-            <a:ext cx="2743200" cy="2194560"/>
+              <a:t>Performance por equipe</a:t>
+            </a:r>
+            <a:endParaRPr lang="en-US" sz="1000" dirty="0"/>
+          </a:p>
+        </p:txBody>
+      </p:sp>
+      <p:sp>
+        <p:nvSpPr>
+          <p:cNvPr id="61" name="Shape 59"/>
+          <p:cNvSpPr/>
+          <p:nvPr/>
+        </p:nvSpPr>
+        <p:spPr>
+          <a:xfrm>
+            <a:off x="9125712" y="3858768"/>
+            <a:ext cx="2468880" cy="1234440"/>
           </a:xfrm>
           <a:prstGeom prst="rect">
             <a:avLst/>
           </a:prstGeom>
           <a:solidFill>
-            <a:srgbClr val="FFFFFF"/>
+            <a:srgbClr val="F4F6FB"/>
           </a:solidFill>
-          <a:ln w="6350">
+          <a:ln w="5080">
             <a:solidFill>
               <a:srgbClr val="E2E8F0"/>
             </a:solidFill>
             <a:prstDash val="solid"/>
           </a:ln>
-          <a:effectLst>
-            <a:outerShdw sx="100000" sy="100000" kx="0" ky="0" algn="bl" rotWithShape="0" blurRad="127000" dist="38100" dir="5400000">
-              <a:srgbClr val="000000">
-                <a:alpha val="10000"/>
-              </a:srgbClr>
-            </a:outerShdw>
-          </a:effectLst>
-        </p:spPr>
-      </p:sp>
-      <p:sp>
-        <p:nvSpPr>
-          <p:cNvPr id="31" name="Shape 24"/>
-          <p:cNvSpPr/>
-          <p:nvPr/>
-        </p:nvSpPr>
-        <p:spPr>
-          <a:xfrm>
-            <a:off x="3282696" y="4069080"/>
-            <a:ext cx="2743200" cy="73152"/>
+        </p:spPr>
+      </p:sp>
+      <p:sp>
+        <p:nvSpPr>
+          <p:cNvPr id="62" name="Shape 60"/>
+          <p:cNvSpPr/>
+          <p:nvPr/>
+        </p:nvSpPr>
+        <p:spPr>
+          <a:xfrm>
+            <a:off x="9125712" y="3858768"/>
+            <a:ext cx="73152" cy="1234440"/>
           </a:xfrm>
           <a:prstGeom prst="rect">
             <a:avLst/>
           </a:prstGeom>
           <a:solidFill>
-            <a:srgbClr val="0A1940"/>
+            <a:srgbClr val="1558CC"/>
           </a:solidFill>
           <a:ln w="12700">
             <a:solidFill>
-              <a:srgbClr val="0A1940"/>
+              <a:srgbClr val="1558CC"/>
             </a:solidFill>
             <a:prstDash val="solid"/>
           </a:ln>
         </p:spPr>
       </p:sp>
-      <p:pic>
-        <p:nvPicPr>
-          <p:cNvPr id="32" name="Image 5" descr="preencoded.png">    </p:cNvPr>
-          <p:cNvPicPr>
-            <a:picLocks noChangeAspect="1"/>
-          </p:cNvPicPr>
-          <p:nvPr/>
-        </p:nvPicPr>
-        <p:blipFill>
-          <a:blip r:embed="rId6"/>
-          <a:stretch>
-            <a:fillRect/>
-          </a:stretch>
-        </p:blipFill>
-        <p:spPr>
-          <a:xfrm>
-            <a:off x="3557016" y="4434840"/>
-            <a:ext cx="548640" cy="548640"/>
-          </a:xfrm>
-          <a:prstGeom prst="rect">
-            <a:avLst/>
-          </a:prstGeom>
-        </p:spPr>
-      </p:pic>
-      <p:sp>
-        <p:nvSpPr>
-          <p:cNvPr id="33" name="Text 25"/>
-          <p:cNvSpPr/>
-          <p:nvPr/>
-        </p:nvSpPr>
-        <p:spPr>
-          <a:xfrm>
-            <a:off x="3511296" y="5120640"/>
-            <a:ext cx="2286000" cy="365760"/>
-          </a:xfrm>
-          <a:prstGeom prst="rect">
-            <a:avLst/>
-          </a:prstGeom>
-          <a:noFill/>
-          <a:ln/>
-        </p:spPr>
-        <p:txBody>
-          <a:bodyPr wrap="square" lIns="0" tIns="0" rIns="0" bIns="0" rtlCol="0" anchor="ctr"/>
-          <a:lstStyle/>
-          <a:p>
-            <a:pPr indent="0" marL="0">
-              <a:buNone/>
-            </a:pPr>
-            <a:r>
-              <a:rPr lang="en-US" sz="1500" b="1" dirty="0">
+      <p:sp>
+        <p:nvSpPr>
+          <p:cNvPr id="63" name="Text 61"/>
+          <p:cNvSpPr/>
+          <p:nvPr/>
+        </p:nvSpPr>
+        <p:spPr>
+          <a:xfrm>
+            <a:off x="9281160" y="4023360"/>
+            <a:ext cx="2313432" cy="457200"/>
+          </a:xfrm>
+          <a:prstGeom prst="rect">
+            <a:avLst/>
+          </a:prstGeom>
+          <a:noFill/>
+          <a:ln/>
+        </p:spPr>
+        <p:txBody>
+          <a:bodyPr wrap="square" lIns="0" tIns="0" rIns="0" bIns="0" rtlCol="0" anchor="ctr"/>
+          <a:lstStyle/>
+          <a:p>
+            <a:pPr indent="0" marL="0">
+              <a:buNone/>
+            </a:pPr>
+            <a:r>
+              <a:rPr lang="en-US" sz="1300" b="1" dirty="0">
                 <a:solidFill>
                   <a:srgbClr val="0A1940"/>
                 </a:solidFill>
@@ -11731,38 +12725,38 @@
                 <a:ea typeface="Georgia" pitchFamily="34" charset="-122"/>
                 <a:cs typeface="Georgia" pitchFamily="34" charset="-120"/>
               </a:rPr>
-              <a:t>Automações agendadas</a:t>
-            </a:r>
-            <a:endParaRPr lang="en-US" sz="1500" dirty="0"/>
-          </a:p>
-        </p:txBody>
-      </p:sp>
-      <p:sp>
-        <p:nvSpPr>
-          <p:cNvPr id="34" name="Text 26"/>
-          <p:cNvSpPr/>
-          <p:nvPr/>
-        </p:nvSpPr>
-        <p:spPr>
-          <a:xfrm>
-            <a:off x="3511296" y="5440680"/>
-            <a:ext cx="2286000" cy="777240"/>
-          </a:xfrm>
-          <a:prstGeom prst="rect">
-            <a:avLst/>
-          </a:prstGeom>
-          <a:noFill/>
-          <a:ln/>
-        </p:spPr>
-        <p:txBody>
-          <a:bodyPr wrap="square" lIns="0" tIns="0" rIns="0" bIns="0" rtlCol="0" anchor="ctr"/>
-          <a:lstStyle/>
-          <a:p>
-            <a:pPr indent="0" marL="0">
-              <a:buNone/>
-            </a:pPr>
-            <a:r>
-              <a:rPr lang="en-US" sz="1100" dirty="0">
+              <a:t>Balanceador de Agenda</a:t>
+            </a:r>
+            <a:endParaRPr lang="en-US" sz="1300" dirty="0"/>
+          </a:p>
+        </p:txBody>
+      </p:sp>
+      <p:sp>
+        <p:nvSpPr>
+          <p:cNvPr id="64" name="Text 62"/>
+          <p:cNvSpPr/>
+          <p:nvPr/>
+        </p:nvSpPr>
+        <p:spPr>
+          <a:xfrm>
+            <a:off x="9281160" y="4498848"/>
+            <a:ext cx="2313432" cy="502920"/>
+          </a:xfrm>
+          <a:prstGeom prst="rect">
+            <a:avLst/>
+          </a:prstGeom>
+          <a:noFill/>
+          <a:ln/>
+        </p:spPr>
+        <p:txBody>
+          <a:bodyPr wrap="square" lIns="0" tIns="0" rIns="0" bIns="0" rtlCol="0" anchor="ctr"/>
+          <a:lstStyle/>
+          <a:p>
+            <a:pPr indent="0" marL="0">
+              <a:buNone/>
+            </a:pPr>
+            <a:r>
+              <a:rPr lang="en-US" sz="1000" dirty="0">
                 <a:solidFill>
                   <a:srgbClr val="1E293B"/>
                 </a:solidFill>
@@ -11770,119 +12764,88 @@
                 <a:ea typeface="Calibri" pitchFamily="34" charset="-122"/>
                 <a:cs typeface="Calibri" pitchFamily="34" charset="-120"/>
               </a:rPr>
-              <a:t>APScheduler em alta disponibilidade.</a:t>
-            </a:r>
-            <a:endParaRPr lang="en-US" sz="1100" dirty="0"/>
-          </a:p>
-        </p:txBody>
-      </p:sp>
-      <p:sp>
-        <p:nvSpPr>
-          <p:cNvPr id="35" name="Shape 27"/>
-          <p:cNvSpPr/>
-          <p:nvPr/>
-        </p:nvSpPr>
-        <p:spPr>
-          <a:xfrm>
-            <a:off x="6163056" y="4069080"/>
-            <a:ext cx="2743200" cy="2194560"/>
+              <a:t>Redistribuição AO VIVO</a:t>
+            </a:r>
+            <a:endParaRPr lang="en-US" sz="1000" dirty="0"/>
+          </a:p>
+        </p:txBody>
+      </p:sp>
+      <p:sp>
+        <p:nvSpPr>
+          <p:cNvPr id="65" name="Shape 63"/>
+          <p:cNvSpPr/>
+          <p:nvPr/>
+        </p:nvSpPr>
+        <p:spPr>
+          <a:xfrm>
+            <a:off x="9125712" y="5138928"/>
+            <a:ext cx="2468880" cy="1234440"/>
           </a:xfrm>
           <a:prstGeom prst="rect">
             <a:avLst/>
           </a:prstGeom>
           <a:solidFill>
-            <a:srgbClr val="FFFFFF"/>
+            <a:srgbClr val="F4F6FB"/>
           </a:solidFill>
-          <a:ln w="6350">
+          <a:ln w="5080">
             <a:solidFill>
               <a:srgbClr val="E2E8F0"/>
             </a:solidFill>
             <a:prstDash val="solid"/>
           </a:ln>
-          <a:effectLst>
-            <a:outerShdw sx="100000" sy="100000" kx="0" ky="0" algn="bl" rotWithShape="0" blurRad="127000" dist="38100" dir="5400000">
-              <a:srgbClr val="000000">
-                <a:alpha val="10000"/>
-              </a:srgbClr>
-            </a:outerShdw>
-          </a:effectLst>
-        </p:spPr>
-      </p:sp>
-      <p:sp>
-        <p:nvSpPr>
-          <p:cNvPr id="36" name="Shape 28"/>
-          <p:cNvSpPr/>
-          <p:nvPr/>
-        </p:nvSpPr>
-        <p:spPr>
-          <a:xfrm>
-            <a:off x="6163056" y="4069080"/>
-            <a:ext cx="2743200" cy="73152"/>
+        </p:spPr>
+      </p:sp>
+      <p:sp>
+        <p:nvSpPr>
+          <p:cNvPr id="66" name="Shape 64"/>
+          <p:cNvSpPr/>
+          <p:nvPr/>
+        </p:nvSpPr>
+        <p:spPr>
+          <a:xfrm>
+            <a:off x="9125712" y="5138928"/>
+            <a:ext cx="73152" cy="1234440"/>
           </a:xfrm>
           <a:prstGeom prst="rect">
             <a:avLst/>
           </a:prstGeom>
           <a:solidFill>
-            <a:srgbClr val="0A1940"/>
+            <a:srgbClr val="1558CC"/>
           </a:solidFill>
           <a:ln w="12700">
             <a:solidFill>
-              <a:srgbClr val="0A1940"/>
+              <a:srgbClr val="1558CC"/>
             </a:solidFill>
             <a:prstDash val="solid"/>
           </a:ln>
         </p:spPr>
       </p:sp>
-      <p:pic>
-        <p:nvPicPr>
-          <p:cNvPr id="37" name="Image 6" descr="preencoded.png">    </p:cNvPr>
-          <p:cNvPicPr>
-            <a:picLocks noChangeAspect="1"/>
-          </p:cNvPicPr>
-          <p:nvPr/>
-        </p:nvPicPr>
-        <p:blipFill>
-          <a:blip r:embed="rId7"/>
-          <a:stretch>
-            <a:fillRect/>
-          </a:stretch>
-        </p:blipFill>
-        <p:spPr>
-          <a:xfrm>
-            <a:off x="6437376" y="4434840"/>
-            <a:ext cx="548640" cy="548640"/>
-          </a:xfrm>
-          <a:prstGeom prst="rect">
-            <a:avLst/>
-          </a:prstGeom>
-        </p:spPr>
-      </p:pic>
-      <p:sp>
-        <p:nvSpPr>
-          <p:cNvPr id="38" name="Text 29"/>
-          <p:cNvSpPr/>
-          <p:nvPr/>
-        </p:nvSpPr>
-        <p:spPr>
-          <a:xfrm>
-            <a:off x="6391656" y="5120640"/>
-            <a:ext cx="2286000" cy="365760"/>
-          </a:xfrm>
-          <a:prstGeom prst="rect">
-            <a:avLst/>
-          </a:prstGeom>
-          <a:noFill/>
-          <a:ln/>
-        </p:spPr>
-        <p:txBody>
-          <a:bodyPr wrap="square" lIns="0" tIns="0" rIns="0" bIns="0" rtlCol="0" anchor="ctr"/>
-          <a:lstStyle/>
-          <a:p>
-            <a:pPr indent="0" marL="0">
-              <a:buNone/>
-            </a:pPr>
-            <a:r>
-              <a:rPr lang="en-US" sz="1500" b="1" dirty="0">
+      <p:sp>
+        <p:nvSpPr>
+          <p:cNvPr id="67" name="Text 65"/>
+          <p:cNvSpPr/>
+          <p:nvPr/>
+        </p:nvSpPr>
+        <p:spPr>
+          <a:xfrm>
+            <a:off x="9281160" y="5303520"/>
+            <a:ext cx="2313432" cy="457200"/>
+          </a:xfrm>
+          <a:prstGeom prst="rect">
+            <a:avLst/>
+          </a:prstGeom>
+          <a:noFill/>
+          <a:ln/>
+        </p:spPr>
+        <p:txBody>
+          <a:bodyPr wrap="square" lIns="0" tIns="0" rIns="0" bIns="0" rtlCol="0" anchor="ctr"/>
+          <a:lstStyle/>
+          <a:p>
+            <a:pPr indent="0" marL="0">
+              <a:buNone/>
+            </a:pPr>
+            <a:r>
+              <a:rPr lang="en-US" sz="1300" b="1" dirty="0">
                 <a:solidFill>
                   <a:srgbClr val="0A1940"/>
                 </a:solidFill>
@@ -11890,38 +12853,38 @@
                 <a:ea typeface="Georgia" pitchFamily="34" charset="-122"/>
                 <a:cs typeface="Georgia" pitchFamily="34" charset="-120"/>
               </a:rPr>
-              <a:t>Painéis e métricas</a:t>
-            </a:r>
-            <a:endParaRPr lang="en-US" sz="1500" dirty="0"/>
-          </a:p>
-        </p:txBody>
-      </p:sp>
-      <p:sp>
-        <p:nvSpPr>
-          <p:cNvPr id="39" name="Text 30"/>
-          <p:cNvSpPr/>
-          <p:nvPr/>
-        </p:nvSpPr>
-        <p:spPr>
-          <a:xfrm>
-            <a:off x="6391656" y="5440680"/>
-            <a:ext cx="2286000" cy="777240"/>
-          </a:xfrm>
-          <a:prstGeom prst="rect">
-            <a:avLst/>
-          </a:prstGeom>
-          <a:noFill/>
-          <a:ln/>
-        </p:spPr>
-        <p:txBody>
-          <a:bodyPr wrap="square" lIns="0" tIns="0" rIns="0" bIns="0" rtlCol="0" anchor="ctr"/>
-          <a:lstStyle/>
-          <a:p>
-            <a:pPr indent="0" marL="0">
-              <a:buNone/>
-            </a:pPr>
-            <a:r>
-              <a:rPr lang="en-US" sz="1100" dirty="0">
+              <a:t>Administração &amp; Painéis</a:t>
+            </a:r>
+            <a:endParaRPr lang="en-US" sz="1300" dirty="0"/>
+          </a:p>
+        </p:txBody>
+      </p:sp>
+      <p:sp>
+        <p:nvSpPr>
+          <p:cNvPr id="68" name="Text 66"/>
+          <p:cNvSpPr/>
+          <p:nvPr/>
+        </p:nvSpPr>
+        <p:spPr>
+          <a:xfrm>
+            <a:off x="9281160" y="5779008"/>
+            <a:ext cx="2313432" cy="502920"/>
+          </a:xfrm>
+          <a:prstGeom prst="rect">
+            <a:avLst/>
+          </a:prstGeom>
+          <a:noFill/>
+          <a:ln/>
+        </p:spPr>
+        <p:txBody>
+          <a:bodyPr wrap="square" lIns="0" tIns="0" rIns="0" bIns="0" rtlCol="0" anchor="ctr"/>
+          <a:lstStyle/>
+          <a:p>
+            <a:pPr indent="0" marL="0">
+              <a:buNone/>
+            </a:pPr>
+            <a:r>
+              <a:rPr lang="en-US" sz="1000" dirty="0">
                 <a:solidFill>
                   <a:srgbClr val="1E293B"/>
                 </a:solidFill>
@@ -11929,174 +12892,15 @@
                 <a:ea typeface="Calibri" pitchFamily="34" charset="-122"/>
                 <a:cs typeface="Calibri" pitchFamily="34" charset="-120"/>
               </a:rPr>
-              <a:t>Visibilidade do que foi feito, está pendente e travou.</a:t>
-            </a:r>
-            <a:endParaRPr lang="en-US" sz="1100" dirty="0"/>
-          </a:p>
-        </p:txBody>
-      </p:sp>
-      <p:sp>
-        <p:nvSpPr>
-          <p:cNvPr id="40" name="Shape 31"/>
-          <p:cNvSpPr/>
-          <p:nvPr/>
-        </p:nvSpPr>
-        <p:spPr>
-          <a:xfrm>
-            <a:off x="9043416" y="4069080"/>
-            <a:ext cx="2743200" cy="2194560"/>
-          </a:xfrm>
-          <a:prstGeom prst="rect">
-            <a:avLst/>
-          </a:prstGeom>
-          <a:solidFill>
-            <a:srgbClr val="FFFFFF"/>
-          </a:solidFill>
-          <a:ln w="6350">
-            <a:solidFill>
-              <a:srgbClr val="E2E8F0"/>
-            </a:solidFill>
-            <a:prstDash val="solid"/>
-          </a:ln>
-          <a:effectLst>
-            <a:outerShdw sx="100000" sy="100000" kx="0" ky="0" algn="bl" rotWithShape="0" blurRad="127000" dist="38100" dir="5400000">
-              <a:srgbClr val="000000">
-                <a:alpha val="10000"/>
-              </a:srgbClr>
-            </a:outerShdw>
-          </a:effectLst>
-        </p:spPr>
-      </p:sp>
-      <p:sp>
-        <p:nvSpPr>
-          <p:cNvPr id="41" name="Shape 32"/>
-          <p:cNvSpPr/>
-          <p:nvPr/>
-        </p:nvSpPr>
-        <p:spPr>
-          <a:xfrm>
-            <a:off x="9043416" y="4069080"/>
-            <a:ext cx="2743200" cy="73152"/>
-          </a:xfrm>
-          <a:prstGeom prst="rect">
-            <a:avLst/>
-          </a:prstGeom>
-          <a:solidFill>
-            <a:srgbClr val="0A1940"/>
-          </a:solidFill>
-          <a:ln w="12700">
-            <a:solidFill>
-              <a:srgbClr val="0A1940"/>
-            </a:solidFill>
-            <a:prstDash val="solid"/>
-          </a:ln>
-        </p:spPr>
-      </p:sp>
-      <p:pic>
-        <p:nvPicPr>
-          <p:cNvPr id="42" name="Image 7" descr="preencoded.png">    </p:cNvPr>
-          <p:cNvPicPr>
-            <a:picLocks noChangeAspect="1"/>
-          </p:cNvPicPr>
-          <p:nvPr/>
-        </p:nvPicPr>
-        <p:blipFill>
-          <a:blip r:embed="rId8"/>
-          <a:stretch>
-            <a:fillRect/>
-          </a:stretch>
-        </p:blipFill>
-        <p:spPr>
-          <a:xfrm>
-            <a:off x="9317736" y="4434840"/>
-            <a:ext cx="548640" cy="548640"/>
-          </a:xfrm>
-          <a:prstGeom prst="rect">
-            <a:avLst/>
-          </a:prstGeom>
-        </p:spPr>
-      </p:pic>
-      <p:sp>
-        <p:nvSpPr>
-          <p:cNvPr id="43" name="Text 33"/>
-          <p:cNvSpPr/>
-          <p:nvPr/>
-        </p:nvSpPr>
-        <p:spPr>
-          <a:xfrm>
-            <a:off x="9272016" y="5120640"/>
-            <a:ext cx="2286000" cy="365760"/>
-          </a:xfrm>
-          <a:prstGeom prst="rect">
-            <a:avLst/>
-          </a:prstGeom>
-          <a:noFill/>
-          <a:ln/>
-        </p:spPr>
-        <p:txBody>
-          <a:bodyPr wrap="square" lIns="0" tIns="0" rIns="0" bIns="0" rtlCol="0" anchor="ctr"/>
-          <a:lstStyle/>
-          <a:p>
-            <a:pPr indent="0" marL="0">
-              <a:buNone/>
-            </a:pPr>
-            <a:r>
-              <a:rPr lang="en-US" sz="1500" b="1" dirty="0">
-                <a:solidFill>
-                  <a:srgbClr val="0A1940"/>
-                </a:solidFill>
-                <a:latin typeface="Georgia" pitchFamily="34" charset="0"/>
-                <a:ea typeface="Georgia" pitchFamily="34" charset="-122"/>
-                <a:cs typeface="Georgia" pitchFamily="34" charset="-120"/>
-              </a:rPr>
-              <a:t>Administração</a:t>
-            </a:r>
-            <a:endParaRPr lang="en-US" sz="1500" dirty="0"/>
-          </a:p>
-        </p:txBody>
-      </p:sp>
-      <p:sp>
-        <p:nvSpPr>
-          <p:cNvPr id="44" name="Text 34"/>
-          <p:cNvSpPr/>
-          <p:nvPr/>
-        </p:nvSpPr>
-        <p:spPr>
-          <a:xfrm>
-            <a:off x="9272016" y="5440680"/>
-            <a:ext cx="2286000" cy="777240"/>
-          </a:xfrm>
-          <a:prstGeom prst="rect">
-            <a:avLst/>
-          </a:prstGeom>
-          <a:noFill/>
-          <a:ln/>
-        </p:spPr>
-        <p:txBody>
-          <a:bodyPr wrap="square" lIns="0" tIns="0" rIns="0" bIns="0" rtlCol="0" anchor="ctr"/>
-          <a:lstStyle/>
-          <a:p>
-            <a:pPr indent="0" marL="0">
-              <a:buNone/>
-            </a:pPr>
-            <a:r>
-              <a:rPr lang="en-US" sz="1100" dirty="0">
-                <a:solidFill>
-                  <a:srgbClr val="1E293B"/>
-                </a:solidFill>
-                <a:latin typeface="Calibri" pitchFamily="34" charset="0"/>
-                <a:ea typeface="Calibri" pitchFamily="34" charset="-122"/>
-                <a:cs typeface="Calibri" pitchFamily="34" charset="-120"/>
-              </a:rPr>
-              <a:t>Papéis, permissões, catálogos e auditoria.</a:t>
-            </a:r>
-            <a:endParaRPr lang="en-US" sz="1100" dirty="0"/>
-          </a:p>
-        </p:txBody>
-      </p:sp>
-      <p:sp>
-        <p:nvSpPr>
-          <p:cNvPr id="45" name="Shape 35"/>
+              <a:t>Permissões, catálogos, KPIs</a:t>
+            </a:r>
+            <a:endParaRPr lang="en-US" sz="1000" dirty="0"/>
+          </a:p>
+        </p:txBody>
+      </p:sp>
+      <p:sp>
+        <p:nvSpPr>
+          <p:cNvPr id="69" name="Shape 67"/>
           <p:cNvSpPr/>
           <p:nvPr/>
         </p:nvSpPr>
@@ -12119,7 +12923,7 @@
       </p:sp>
       <p:sp>
         <p:nvSpPr>
-          <p:cNvPr id="46" name="Text 36"/>
+          <p:cNvPr id="70" name="Text 68"/>
           <p:cNvSpPr/>
           <p:nvPr/>
         </p:nvSpPr>
@@ -12158,7 +12962,7 @@
       </p:sp>
       <p:sp>
         <p:nvSpPr>
-          <p:cNvPr id="47" name="Text 37"/>
+          <p:cNvPr id="71" name="Text 69"/>
           <p:cNvSpPr/>
           <p:nvPr/>
         </p:nvSpPr>

</xml_diff>